<commit_message>
Add photos to large-font humanoid robots presentation
Co-Authored-By: Claude Sonnet 5.5 <noreply@anthropic.com>
Claude-Session: https://claude.ai/code/session_01QoBEPxbicZNbtosTbAi2im
</commit_message>
<xml_diff>
--- a/Humanoide_Roboter_gross.pptx
+++ b/Humanoide_Roboter_gross.pptx
@@ -137,7 +137,7 @@
   <p:extLst>
     <p:ext uri="{521415D9-36F7-43E2-AB2F-B90AF26B5E84}">
       <p14:sectionLst xmlns:p14="http://schemas.microsoft.com/office/powerpoint/2010/main">
-        <p14:section name="Teil 1: Geschichte der humanoiden Roboter" id="{aefefd20-7278-b603-c874-6640f418d9c3}">
+        <p14:section name="Teil 1: Geschichte der humanoiden Roboter" id="{7b2e4899-ef13-2ea7-3c4a-c8af2143a209}">
           <p14:sldIdLst>
             <p14:sldId id="257"/>
             <p14:sldId id="258"/>
@@ -146,7 +146,7 @@
             <p14:sldId id="261"/>
           </p14:sldIdLst>
         </p14:section>
-        <p14:section name="Teil 2: Sport, Athletik und Wettkämpfe" id="{43bdfe6e-d6c1-b4a5-2023-b1ef501aeac6}">
+        <p14:section name="Teil 2: Sport, Athletik und Wettkämpfe" id="{7ad5eee4-c09b-2c78-f9e7-385954bf3269}">
           <p14:sldIdLst>
             <p14:sldId id="262"/>
             <p14:sldId id="263"/>
@@ -156,7 +156,7 @@
             <p14:sldId id="267"/>
           </p14:sldIdLst>
         </p14:section>
-        <p14:section name="Teil 3: Industrie &amp; Fabriken" id="{28d95caf-802d-f879-0a9f-37a25dc6f481}">
+        <p14:section name="Teil 3: Industrie &amp; Fabriken" id="{4e3b65bb-26b3-e960-2c5f-9340b27e64d7}">
           <p14:sldIdLst>
             <p14:sldId id="268"/>
             <p14:sldId id="269"/>
@@ -166,7 +166,7 @@
             <p14:sldId id="273"/>
           </p14:sldIdLst>
         </p14:section>
-        <p14:section name="Teil 4: Künstliche Intelligenz &amp; Schlüsseltechnologien" id="{1a7ee5d1-657e-eea4-6daa-96e21e3bc205}">
+        <p14:section name="Teil 4: Künstliche Intelligenz &amp; Schlüsseltechnologien" id="{00005871-94af-a3bf-8657-4922341c34cd}">
           <p14:sldIdLst>
             <p14:sldId id="274"/>
             <p14:sldId id="275"/>
@@ -176,7 +176,7 @@
             <p14:sldId id="279"/>
           </p14:sldIdLst>
         </p14:section>
-        <p14:section name="Teil 5: Haushaltsroboter &amp; Zukunftsprognosen" id="{af502e69-b23c-e290-44ea-c3c78379c263}">
+        <p14:section name="Teil 5: Haushaltsroboter &amp; Zukunftsprognosen" id="{7e337701-efab-4a25-d548-0f2628691a7b}">
           <p14:sldIdLst>
             <p14:sldId id="280"/>
             <p14:sldId id="281"/>
@@ -1119,7 +1119,7 @@
           <a:p>
             <a:r>
               <a:rPr lang="en-US" dirty="0"/>
-              <a:t>Bildmotiv: Präzisionskamera am Kopf des Roboters scannt glänzende Karosserieteile ab.</a:t>
+              <a:t>Bildmotiv: Präzisionskamera am Kopf des Roboters scannt glänzende Karosserieteile ab. | Foto: Illustrationsfoto, Wikimedia Commons (Lizenz vor Veröffentlichung prüfen).</a:t>
             </a:r>
             <a:endParaRPr lang="en-US" dirty="0"/>
           </a:p>
@@ -1207,7 +1207,7 @@
           <a:p>
             <a:r>
               <a:rPr lang="en-US" dirty="0"/>
-              <a:t>Bildmotiv: Der schwarze humanoide Roboter Figure 02 montiert Metallteile in der Fabrik.</a:t>
+              <a:t>Bildmotiv: Der schwarze humanoide Roboter Figure 02 montiert Metallteile in der Fabrik. | Foto: Illustrationsfoto, Wikimedia Commons (Lizenz vor Veröffentlichung prüfen).</a:t>
             </a:r>
             <a:endParaRPr lang="en-US" dirty="0"/>
           </a:p>
@@ -1295,7 +1295,7 @@
           <a:p>
             <a:r>
               <a:rPr lang="en-US" dirty="0"/>
-              <a:t>Bildmotiv: Humanoider Roboter dockt mit dem Rücken an eine magnetische Ladesäule an.</a:t>
+              <a:t>Bildmotiv: Humanoider Roboter dockt mit dem Rücken an eine magnetische Ladesäule an. | Foto: Illustrationsfoto, Wikimedia Commons (Lizenz vor Veröffentlichung prüfen).</a:t>
             </a:r>
             <a:endParaRPr lang="en-US" dirty="0"/>
           </a:p>
@@ -1383,7 +1383,7 @@
           <a:p>
             <a:r>
               <a:rPr lang="en-US" dirty="0"/>
-              <a:t>Bildmotiv: Weltkarte mit leuchtenden Innovationszentren für fortschrittliche Robotik.</a:t>
+              <a:t>Bildmotiv: Weltkarte mit leuchtenden Innovationszentren für fortschrittliche Robotik. | Foto: Illustrationsfoto, Wikimedia Commons (Lizenz vor Veröffentlichung prüfen).</a:t>
             </a:r>
             <a:endParaRPr lang="en-US" dirty="0"/>
           </a:p>
@@ -1647,7 +1647,7 @@
           <a:p>
             <a:r>
               <a:rPr lang="en-US" dirty="0"/>
-              <a:t>Bildmotiv: Taktile Roboterfinger mit weichen Silikonkappen greifen behutsam ein Hühnerei.</a:t>
+              <a:t>Bildmotiv: Taktile Roboterfinger mit weichen Silikonkappen greifen behutsam ein Hühnerei. | Foto: Illustrationsfoto, Wikimedia Commons (Lizenz vor Veröffentlichung prüfen).</a:t>
             </a:r>
             <a:endParaRPr lang="en-US" dirty="0"/>
           </a:p>
@@ -1823,7 +1823,7 @@
           <a:p>
             <a:r>
               <a:rPr lang="en-US" dirty="0"/>
-              <a:t>Bildmotiv: Sanfte Berührung zwischen einem menschlichen Arm und einem weich nachgebenden Roboterarm.</a:t>
+              <a:t>Bildmotiv: Sanfte Berührung zwischen einem menschlichen Arm und einem weich nachgebenden Roboterarm. | Foto: Illustrationsfoto, Wikimedia Commons (Lizenz vor Veröffentlichung prüfen).</a:t>
             </a:r>
             <a:endParaRPr lang="en-US" dirty="0"/>
           </a:p>
@@ -1911,7 +1911,7 @@
           <a:p>
             <a:r>
               <a:rPr lang="en-US" dirty="0"/>
-              <a:t>Bildmotiv: Querschnitt eines Elektromotors und ein modulares Akkupaket.</a:t>
+              <a:t>Bildmotiv: Querschnitt eines Elektromotors und ein modulares Akkupaket. | Foto: Illustrationsfoto, Wikimedia Commons (Lizenz vor Veröffentlichung prüfen).</a:t>
             </a:r>
             <a:endParaRPr lang="en-US" dirty="0"/>
           </a:p>
@@ -1999,7 +1999,7 @@
           <a:p>
             <a:r>
               <a:rPr lang="en-US" dirty="0"/>
-              <a:t>Bildmotiv: 3D-Tiefenkarte eines Wohnraums mit erkannten Objekten und Hindernissen.</a:t>
+              <a:t>Bildmotiv: 3D-Tiefenkarte eines Wohnraums mit erkannten Objekten und Hindernissen. | Foto: Illustrationsfoto, Wikimedia Commons (Lizenz vor Veröffentlichung prüfen).</a:t>
             </a:r>
             <a:endParaRPr lang="en-US" dirty="0"/>
           </a:p>
@@ -2263,7 +2263,7 @@
           <a:p>
             <a:r>
               <a:rPr lang="en-US" dirty="0"/>
-              <a:t>Bildmotiv: Roboter stützt sanft eine ältere Person beim Gehen im Flur eines Seniorenheims.</a:t>
+              <a:t>Bildmotiv: Roboter stützt sanft eine ältere Person beim Gehen im Flur eines Seniorenheims. | Foto: Illustrationsfoto, Wikimedia Commons (Lizenz vor Veröffentlichung prüfen).</a:t>
             </a:r>
             <a:endParaRPr lang="en-US" dirty="0"/>
           </a:p>
@@ -2439,7 +2439,7 @@
           <a:p>
             <a:r>
               <a:rPr lang="en-US" dirty="0"/>
-              <a:t>Bildmotiv: Ein digitales Schloss-Symbol vor einem Wohnzimmer-Hintergrund für Datenschutz.</a:t>
+              <a:t>Bildmotiv: Ein digitales Schloss-Symbol vor einem Wohnzimmer-Hintergrund für Datenschutz. | Foto: Illustrationsfoto, Wikimedia Commons (Lizenz vor Veröffentlichung prüfen).</a:t>
             </a:r>
             <a:endParaRPr lang="en-US" dirty="0"/>
           </a:p>
@@ -2615,7 +2615,7 @@
           <a:p>
             <a:r>
               <a:rPr lang="en-US" dirty="0"/>
-              <a:t>Bildmotiv: Ingenieure prüfen neue Materialien und Batterien im Entwicklungszentrum.</a:t>
+              <a:t>Bildmotiv: Ingenieure prüfen neue Materialien und Batterien im Entwicklungszentrum. | Foto: Illustrationsfoto, Wikimedia Commons (Lizenz vor Veröffentlichung prüfen).</a:t>
             </a:r>
             <a:endParaRPr lang="en-US" dirty="0"/>
           </a:p>
@@ -2703,7 +2703,7 @@
           <a:p>
             <a:r>
               <a:rPr lang="en-US" dirty="0"/>
-              <a:t>Bildmotiv: Mensch und humanoider Roboter stehen gemeinsam auf einer Aussichtsplattform.</a:t>
+              <a:t>Bildmotiv: Mensch und humanoider Roboter stehen gemeinsam auf einer Aussichtsplattform. | Foto: Illustrationsfoto, Wikimedia Commons (Lizenz vor Veröffentlichung prüfen).</a:t>
             </a:r>
             <a:endParaRPr lang="en-US" dirty="0"/>
           </a:p>
@@ -3055,7 +3055,7 @@
           <a:p>
             <a:r>
               <a:rPr lang="en-US" dirty="0"/>
-              <a:t>Bildmotiv: Zweibeinige Roboter an der Startlinie einer roten Stadion-Laufbahn und beim Fußball.</a:t>
+              <a:t>Bildmotiv: Zweibeinige Roboter an der Startlinie einer roten Stadion-Laufbahn und beim Fußball. | Foto: Illustrationsfoto, Wikimedia Commons (Lizenz vor Veröffentlichung prüfen).</a:t>
             </a:r>
             <a:endParaRPr lang="en-US" dirty="0"/>
           </a:p>
@@ -5638,43 +5638,40 @@
           </a:p>
         </p:txBody>
       </p:sp>
-      <p:sp>
-        <p:nvSpPr>
-          <p:cNvPr id="6" name="Bildplatzhalter"/>
-          <p:cNvSpPr/>
-          <p:nvPr/>
-        </p:nvSpPr>
-        <p:spPr>
-          <a:xfrm>
-            <a:off x="6217920" y="822960"/>
-            <a:ext cx="2514600" cy="2651760"/>
-          </a:xfrm>
-          <a:prstGeom prst="roundRect">
-            <a:avLst>
-              <a:gd name="adj" fmla="val 5455"/>
-            </a:avLst>
-          </a:prstGeom>
-          <a:solidFill>
-            <a:srgbClr val="12304D"/>
-          </a:solidFill>
-          <a:ln w="12700">
-            <a:solidFill>
-              <a:srgbClr val="12304D"/>
-            </a:solidFill>
-            <a:prstDash val="solid"/>
-          </a:ln>
-        </p:spPr>
-      </p:sp>
-      <p:sp>
-        <p:nvSpPr>
-          <p:cNvPr id="7" name="Text 5"/>
-          <p:cNvSpPr txBox="1"/>
-          <p:nvPr/>
-        </p:nvSpPr>
-        <p:spPr>
-          <a:xfrm>
-            <a:off x="6217920" y="960120"/>
-            <a:ext cx="2514600" cy="822960"/>
+      <p:pic>
+        <p:nvPicPr>
+          <p:cNvPr id="6" name="Foto" descr="Präzisionskamera am Kopf des Roboters scannt glänzende Karosserieteile ab.">    </p:cNvPr>
+          <p:cNvPicPr>
+            <a:picLocks noChangeAspect="1"/>
+          </p:cNvPicPr>
+          <p:nvPr/>
+        </p:nvPicPr>
+        <p:blipFill>
+          <a:blip r:embed="rId1"/>
+          <a:stretch>
+            <a:fillRect/>
+          </a:stretch>
+        </p:blipFill>
+        <p:spPr>
+          <a:xfrm>
+            <a:off x="6217920" y="457200"/>
+            <a:ext cx="2514600" cy="3291840"/>
+          </a:xfrm>
+          <a:prstGeom prst="rect">
+            <a:avLst/>
+          </a:prstGeom>
+        </p:spPr>
+      </p:pic>
+      <p:sp>
+        <p:nvSpPr>
+          <p:cNvPr id="7" name="Text 4"/>
+          <p:cNvSpPr txBox="1"/>
+          <p:nvPr/>
+        </p:nvSpPr>
+        <p:spPr>
+          <a:xfrm>
+            <a:off x="6217920" y="3822192"/>
+            <a:ext cx="2514600" cy="201168"/>
           </a:xfrm>
           <a:prstGeom prst="rect">
             <a:avLst/>
@@ -5686,82 +5683,7 @@
           <a:bodyPr wrap="square" lIns="0" tIns="0" rIns="0" bIns="0" rtlCol="0" anchor="ctr"/>
           <a:lstStyle/>
           <a:p>
-            <a:pPr algn="ctr" indent="0" marL="0">
-              <a:buNone/>
-            </a:pPr>
-            <a:r>
-              <a:rPr lang="en-US" sz="5400" b="1" dirty="0">
-                <a:solidFill>
-                  <a:srgbClr val="FF7A1A"/>
-                </a:solidFill>
-                <a:latin typeface="Cambria" pitchFamily="34" charset="0"/>
-                <a:ea typeface="Cambria" pitchFamily="34" charset="-122"/>
-                <a:cs typeface="Cambria" pitchFamily="34" charset="-120"/>
-              </a:rPr>
-              <a:t>14</a:t>
-            </a:r>
-            <a:endParaRPr lang="en-US" sz="5400" dirty="0"/>
-          </a:p>
-        </p:txBody>
-      </p:sp>
-      <p:sp>
-        <p:nvSpPr>
-          <p:cNvPr id="8" name="Text 6"/>
-          <p:cNvSpPr txBox="1"/>
-          <p:nvPr/>
-        </p:nvSpPr>
-        <p:spPr>
-          <a:xfrm>
-            <a:off x="6446520" y="1874520"/>
-            <a:ext cx="2057400" cy="1463040"/>
-          </a:xfrm>
-          <a:prstGeom prst="rect">
-            <a:avLst/>
-          </a:prstGeom>
-          <a:noFill/>
-          <a:ln/>
-        </p:spPr>
-        <p:txBody>
-          <a:bodyPr wrap="square" lIns="0" tIns="0" rIns="0" bIns="0" rtlCol="0" anchor="t"/>
-          <a:lstStyle/>
-          <a:p>
-            <a:pPr algn="ctr" indent="0" marL="0">
-              <a:buNone/>
-            </a:pPr>
-            <a:r>
-              <a:rPr lang="en-US" sz="1300" i="1" dirty="0">
-                <a:solidFill>
-                  <a:srgbClr val="EAF1F7"/>
-                </a:solidFill>
-              </a:rPr>
-              <a:t>Präzisionskamera am Kopf des Roboters scannt glänzende Karosserieteile ab.</a:t>
-            </a:r>
-            <a:endParaRPr lang="en-US" sz="1300" dirty="0"/>
-          </a:p>
-        </p:txBody>
-      </p:sp>
-      <p:sp>
-        <p:nvSpPr>
-          <p:cNvPr id="9" name="Text 7"/>
-          <p:cNvSpPr txBox="1"/>
-          <p:nvPr/>
-        </p:nvSpPr>
-        <p:spPr>
-          <a:xfrm>
-            <a:off x="6217920" y="3566160"/>
-            <a:ext cx="2514600" cy="228600"/>
-          </a:xfrm>
-          <a:prstGeom prst="rect">
-            <a:avLst/>
-          </a:prstGeom>
-          <a:noFill/>
-          <a:ln/>
-        </p:spPr>
-        <p:txBody>
-          <a:bodyPr wrap="square" lIns="0" tIns="0" rIns="0" bIns="0" rtlCol="0" anchor="ctr"/>
-          <a:lstStyle/>
-          <a:p>
-            <a:pPr algn="ctr" indent="0" marL="0">
+            <a:pPr indent="0" marL="0">
               <a:buNone/>
             </a:pPr>
             <a:r>
@@ -5770,7 +5692,7 @@
                   <a:srgbClr val="5B7C99"/>
                 </a:solidFill>
               </a:rPr>
-              <a:t>Bildmotiv (Platzhalter)</a:t>
+              <a:t>Foto: Illustrationsfoto / Wikimedia Commons</a:t>
             </a:r>
             <a:endParaRPr lang="en-US" sz="1000" dirty="0"/>
           </a:p>
@@ -5950,43 +5872,40 @@
           </a:p>
         </p:txBody>
       </p:sp>
-      <p:sp>
-        <p:nvSpPr>
-          <p:cNvPr id="6" name="Bildplatzhalter"/>
-          <p:cNvSpPr/>
-          <p:nvPr/>
-        </p:nvSpPr>
-        <p:spPr>
-          <a:xfrm>
-            <a:off x="6217920" y="822960"/>
-            <a:ext cx="2514600" cy="2651760"/>
-          </a:xfrm>
-          <a:prstGeom prst="roundRect">
-            <a:avLst>
-              <a:gd name="adj" fmla="val 5455"/>
-            </a:avLst>
-          </a:prstGeom>
-          <a:solidFill>
-            <a:srgbClr val="12304D"/>
-          </a:solidFill>
-          <a:ln w="12700">
-            <a:solidFill>
-              <a:srgbClr val="12304D"/>
-            </a:solidFill>
-            <a:prstDash val="solid"/>
-          </a:ln>
-        </p:spPr>
-      </p:sp>
-      <p:sp>
-        <p:nvSpPr>
-          <p:cNvPr id="7" name="Text 5"/>
-          <p:cNvSpPr txBox="1"/>
-          <p:nvPr/>
-        </p:nvSpPr>
-        <p:spPr>
-          <a:xfrm>
-            <a:off x="6217920" y="960120"/>
-            <a:ext cx="2514600" cy="822960"/>
+      <p:pic>
+        <p:nvPicPr>
+          <p:cNvPr id="6" name="Foto" descr="Der schwarze humanoide Roboter Figure 02 montiert Metallteile in der Fabrik.">    </p:cNvPr>
+          <p:cNvPicPr>
+            <a:picLocks noChangeAspect="1"/>
+          </p:cNvPicPr>
+          <p:nvPr/>
+        </p:nvPicPr>
+        <p:blipFill>
+          <a:blip r:embed="rId1"/>
+          <a:stretch>
+            <a:fillRect/>
+          </a:stretch>
+        </p:blipFill>
+        <p:spPr>
+          <a:xfrm>
+            <a:off x="6217920" y="457200"/>
+            <a:ext cx="2514600" cy="3291840"/>
+          </a:xfrm>
+          <a:prstGeom prst="rect">
+            <a:avLst/>
+          </a:prstGeom>
+        </p:spPr>
+      </p:pic>
+      <p:sp>
+        <p:nvSpPr>
+          <p:cNvPr id="7" name="Text 4"/>
+          <p:cNvSpPr txBox="1"/>
+          <p:nvPr/>
+        </p:nvSpPr>
+        <p:spPr>
+          <a:xfrm>
+            <a:off x="6217920" y="3822192"/>
+            <a:ext cx="2514600" cy="201168"/>
           </a:xfrm>
           <a:prstGeom prst="rect">
             <a:avLst/>
@@ -5998,82 +5917,7 @@
           <a:bodyPr wrap="square" lIns="0" tIns="0" rIns="0" bIns="0" rtlCol="0" anchor="ctr"/>
           <a:lstStyle/>
           <a:p>
-            <a:pPr algn="ctr" indent="0" marL="0">
-              <a:buNone/>
-            </a:pPr>
-            <a:r>
-              <a:rPr lang="en-US" sz="5400" b="1" dirty="0">
-                <a:solidFill>
-                  <a:srgbClr val="FF7A1A"/>
-                </a:solidFill>
-                <a:latin typeface="Cambria" pitchFamily="34" charset="0"/>
-                <a:ea typeface="Cambria" pitchFamily="34" charset="-122"/>
-                <a:cs typeface="Cambria" pitchFamily="34" charset="-120"/>
-              </a:rPr>
-              <a:t>15</a:t>
-            </a:r>
-            <a:endParaRPr lang="en-US" sz="5400" dirty="0"/>
-          </a:p>
-        </p:txBody>
-      </p:sp>
-      <p:sp>
-        <p:nvSpPr>
-          <p:cNvPr id="8" name="Text 6"/>
-          <p:cNvSpPr txBox="1"/>
-          <p:nvPr/>
-        </p:nvSpPr>
-        <p:spPr>
-          <a:xfrm>
-            <a:off x="6446520" y="1874520"/>
-            <a:ext cx="2057400" cy="1463040"/>
-          </a:xfrm>
-          <a:prstGeom prst="rect">
-            <a:avLst/>
-          </a:prstGeom>
-          <a:noFill/>
-          <a:ln/>
-        </p:spPr>
-        <p:txBody>
-          <a:bodyPr wrap="square" lIns="0" tIns="0" rIns="0" bIns="0" rtlCol="0" anchor="t"/>
-          <a:lstStyle/>
-          <a:p>
-            <a:pPr algn="ctr" indent="0" marL="0">
-              <a:buNone/>
-            </a:pPr>
-            <a:r>
-              <a:rPr lang="en-US" sz="1300" i="1" dirty="0">
-                <a:solidFill>
-                  <a:srgbClr val="EAF1F7"/>
-                </a:solidFill>
-              </a:rPr>
-              <a:t>Der schwarze humanoide Roboter Figure 02 montiert Metallteile in der Fabrik.</a:t>
-            </a:r>
-            <a:endParaRPr lang="en-US" sz="1300" dirty="0"/>
-          </a:p>
-        </p:txBody>
-      </p:sp>
-      <p:sp>
-        <p:nvSpPr>
-          <p:cNvPr id="9" name="Text 7"/>
-          <p:cNvSpPr txBox="1"/>
-          <p:nvPr/>
-        </p:nvSpPr>
-        <p:spPr>
-          <a:xfrm>
-            <a:off x="6217920" y="3566160"/>
-            <a:ext cx="2514600" cy="228600"/>
-          </a:xfrm>
-          <a:prstGeom prst="rect">
-            <a:avLst/>
-          </a:prstGeom>
-          <a:noFill/>
-          <a:ln/>
-        </p:spPr>
-        <p:txBody>
-          <a:bodyPr wrap="square" lIns="0" tIns="0" rIns="0" bIns="0" rtlCol="0" anchor="ctr"/>
-          <a:lstStyle/>
-          <a:p>
-            <a:pPr algn="ctr" indent="0" marL="0">
+            <a:pPr indent="0" marL="0">
               <a:buNone/>
             </a:pPr>
             <a:r>
@@ -6082,7 +5926,7 @@
                   <a:srgbClr val="5B7C99"/>
                 </a:solidFill>
               </a:rPr>
-              <a:t>Bildmotiv (Platzhalter)</a:t>
+              <a:t>Foto: Illustrationsfoto / Wikimedia Commons</a:t>
             </a:r>
             <a:endParaRPr lang="en-US" sz="1000" dirty="0"/>
           </a:p>
@@ -6262,43 +6106,40 @@
           </a:p>
         </p:txBody>
       </p:sp>
-      <p:sp>
-        <p:nvSpPr>
-          <p:cNvPr id="6" name="Bildplatzhalter"/>
-          <p:cNvSpPr/>
-          <p:nvPr/>
-        </p:nvSpPr>
-        <p:spPr>
-          <a:xfrm>
-            <a:off x="6217920" y="822960"/>
-            <a:ext cx="2514600" cy="2651760"/>
-          </a:xfrm>
-          <a:prstGeom prst="roundRect">
-            <a:avLst>
-              <a:gd name="adj" fmla="val 5455"/>
-            </a:avLst>
-          </a:prstGeom>
-          <a:solidFill>
-            <a:srgbClr val="12304D"/>
-          </a:solidFill>
-          <a:ln w="12700">
-            <a:solidFill>
-              <a:srgbClr val="12304D"/>
-            </a:solidFill>
-            <a:prstDash val="solid"/>
-          </a:ln>
-        </p:spPr>
-      </p:sp>
-      <p:sp>
-        <p:nvSpPr>
-          <p:cNvPr id="7" name="Text 5"/>
-          <p:cNvSpPr txBox="1"/>
-          <p:nvPr/>
-        </p:nvSpPr>
-        <p:spPr>
-          <a:xfrm>
-            <a:off x="6217920" y="960120"/>
-            <a:ext cx="2514600" cy="822960"/>
+      <p:pic>
+        <p:nvPicPr>
+          <p:cNvPr id="6" name="Foto" descr="Humanoider Roboter dockt mit dem Rücken an eine magnetische Ladesäule an.">    </p:cNvPr>
+          <p:cNvPicPr>
+            <a:picLocks noChangeAspect="1"/>
+          </p:cNvPicPr>
+          <p:nvPr/>
+        </p:nvPicPr>
+        <p:blipFill>
+          <a:blip r:embed="rId1"/>
+          <a:stretch>
+            <a:fillRect/>
+          </a:stretch>
+        </p:blipFill>
+        <p:spPr>
+          <a:xfrm>
+            <a:off x="6217920" y="457200"/>
+            <a:ext cx="2514600" cy="3291840"/>
+          </a:xfrm>
+          <a:prstGeom prst="rect">
+            <a:avLst/>
+          </a:prstGeom>
+        </p:spPr>
+      </p:pic>
+      <p:sp>
+        <p:nvSpPr>
+          <p:cNvPr id="7" name="Text 4"/>
+          <p:cNvSpPr txBox="1"/>
+          <p:nvPr/>
+        </p:nvSpPr>
+        <p:spPr>
+          <a:xfrm>
+            <a:off x="6217920" y="3822192"/>
+            <a:ext cx="2514600" cy="201168"/>
           </a:xfrm>
           <a:prstGeom prst="rect">
             <a:avLst/>
@@ -6310,82 +6151,7 @@
           <a:bodyPr wrap="square" lIns="0" tIns="0" rIns="0" bIns="0" rtlCol="0" anchor="ctr"/>
           <a:lstStyle/>
           <a:p>
-            <a:pPr algn="ctr" indent="0" marL="0">
-              <a:buNone/>
-            </a:pPr>
-            <a:r>
-              <a:rPr lang="en-US" sz="5400" b="1" dirty="0">
-                <a:solidFill>
-                  <a:srgbClr val="FF7A1A"/>
-                </a:solidFill>
-                <a:latin typeface="Cambria" pitchFamily="34" charset="0"/>
-                <a:ea typeface="Cambria" pitchFamily="34" charset="-122"/>
-                <a:cs typeface="Cambria" pitchFamily="34" charset="-120"/>
-              </a:rPr>
-              <a:t>16</a:t>
-            </a:r>
-            <a:endParaRPr lang="en-US" sz="5400" dirty="0"/>
-          </a:p>
-        </p:txBody>
-      </p:sp>
-      <p:sp>
-        <p:nvSpPr>
-          <p:cNvPr id="8" name="Text 6"/>
-          <p:cNvSpPr txBox="1"/>
-          <p:nvPr/>
-        </p:nvSpPr>
-        <p:spPr>
-          <a:xfrm>
-            <a:off x="6446520" y="1874520"/>
-            <a:ext cx="2057400" cy="1463040"/>
-          </a:xfrm>
-          <a:prstGeom prst="rect">
-            <a:avLst/>
-          </a:prstGeom>
-          <a:noFill/>
-          <a:ln/>
-        </p:spPr>
-        <p:txBody>
-          <a:bodyPr wrap="square" lIns="0" tIns="0" rIns="0" bIns="0" rtlCol="0" anchor="t"/>
-          <a:lstStyle/>
-          <a:p>
-            <a:pPr algn="ctr" indent="0" marL="0">
-              <a:buNone/>
-            </a:pPr>
-            <a:r>
-              <a:rPr lang="en-US" sz="1300" i="1" dirty="0">
-                <a:solidFill>
-                  <a:srgbClr val="EAF1F7"/>
-                </a:solidFill>
-              </a:rPr>
-              <a:t>Humanoider Roboter dockt mit dem Rücken an eine magnetische Ladesäule an.</a:t>
-            </a:r>
-            <a:endParaRPr lang="en-US" sz="1300" dirty="0"/>
-          </a:p>
-        </p:txBody>
-      </p:sp>
-      <p:sp>
-        <p:nvSpPr>
-          <p:cNvPr id="9" name="Text 7"/>
-          <p:cNvSpPr txBox="1"/>
-          <p:nvPr/>
-        </p:nvSpPr>
-        <p:spPr>
-          <a:xfrm>
-            <a:off x="6217920" y="3566160"/>
-            <a:ext cx="2514600" cy="228600"/>
-          </a:xfrm>
-          <a:prstGeom prst="rect">
-            <a:avLst/>
-          </a:prstGeom>
-          <a:noFill/>
-          <a:ln/>
-        </p:spPr>
-        <p:txBody>
-          <a:bodyPr wrap="square" lIns="0" tIns="0" rIns="0" bIns="0" rtlCol="0" anchor="ctr"/>
-          <a:lstStyle/>
-          <a:p>
-            <a:pPr algn="ctr" indent="0" marL="0">
+            <a:pPr indent="0" marL="0">
               <a:buNone/>
             </a:pPr>
             <a:r>
@@ -6394,7 +6160,7 @@
                   <a:srgbClr val="5B7C99"/>
                 </a:solidFill>
               </a:rPr>
-              <a:t>Bildmotiv (Platzhalter)</a:t>
+              <a:t>Foto: Illustrationsfoto / Wikimedia Commons</a:t>
             </a:r>
             <a:endParaRPr lang="en-US" sz="1000" dirty="0"/>
           </a:p>
@@ -6574,43 +6340,40 @@
           </a:p>
         </p:txBody>
       </p:sp>
-      <p:sp>
-        <p:nvSpPr>
-          <p:cNvPr id="6" name="Bildplatzhalter"/>
-          <p:cNvSpPr/>
-          <p:nvPr/>
-        </p:nvSpPr>
-        <p:spPr>
-          <a:xfrm>
-            <a:off x="6217920" y="822960"/>
-            <a:ext cx="2514600" cy="2651760"/>
-          </a:xfrm>
-          <a:prstGeom prst="roundRect">
-            <a:avLst>
-              <a:gd name="adj" fmla="val 5455"/>
-            </a:avLst>
-          </a:prstGeom>
-          <a:solidFill>
-            <a:srgbClr val="12304D"/>
-          </a:solidFill>
-          <a:ln w="12700">
-            <a:solidFill>
-              <a:srgbClr val="12304D"/>
-            </a:solidFill>
-            <a:prstDash val="solid"/>
-          </a:ln>
-        </p:spPr>
-      </p:sp>
-      <p:sp>
-        <p:nvSpPr>
-          <p:cNvPr id="7" name="Text 5"/>
-          <p:cNvSpPr txBox="1"/>
-          <p:nvPr/>
-        </p:nvSpPr>
-        <p:spPr>
-          <a:xfrm>
-            <a:off x="6217920" y="960120"/>
-            <a:ext cx="2514600" cy="822960"/>
+      <p:pic>
+        <p:nvPicPr>
+          <p:cNvPr id="6" name="Foto" descr="Weltkarte mit leuchtenden Innovationszentren für fortschrittliche Robotik.">    </p:cNvPr>
+          <p:cNvPicPr>
+            <a:picLocks noChangeAspect="1"/>
+          </p:cNvPicPr>
+          <p:nvPr/>
+        </p:nvPicPr>
+        <p:blipFill>
+          <a:blip r:embed="rId1"/>
+          <a:stretch>
+            <a:fillRect/>
+          </a:stretch>
+        </p:blipFill>
+        <p:spPr>
+          <a:xfrm>
+            <a:off x="6217920" y="457200"/>
+            <a:ext cx="2514600" cy="3291840"/>
+          </a:xfrm>
+          <a:prstGeom prst="rect">
+            <a:avLst/>
+          </a:prstGeom>
+        </p:spPr>
+      </p:pic>
+      <p:sp>
+        <p:nvSpPr>
+          <p:cNvPr id="7" name="Text 4"/>
+          <p:cNvSpPr txBox="1"/>
+          <p:nvPr/>
+        </p:nvSpPr>
+        <p:spPr>
+          <a:xfrm>
+            <a:off x="6217920" y="3822192"/>
+            <a:ext cx="2514600" cy="201168"/>
           </a:xfrm>
           <a:prstGeom prst="rect">
             <a:avLst/>
@@ -6622,82 +6385,7 @@
           <a:bodyPr wrap="square" lIns="0" tIns="0" rIns="0" bIns="0" rtlCol="0" anchor="ctr"/>
           <a:lstStyle/>
           <a:p>
-            <a:pPr algn="ctr" indent="0" marL="0">
-              <a:buNone/>
-            </a:pPr>
-            <a:r>
-              <a:rPr lang="en-US" sz="5400" b="1" dirty="0">
-                <a:solidFill>
-                  <a:srgbClr val="FF7A1A"/>
-                </a:solidFill>
-                <a:latin typeface="Cambria" pitchFamily="34" charset="0"/>
-                <a:ea typeface="Cambria" pitchFamily="34" charset="-122"/>
-                <a:cs typeface="Cambria" pitchFamily="34" charset="-120"/>
-              </a:rPr>
-              <a:t>17</a:t>
-            </a:r>
-            <a:endParaRPr lang="en-US" sz="5400" dirty="0"/>
-          </a:p>
-        </p:txBody>
-      </p:sp>
-      <p:sp>
-        <p:nvSpPr>
-          <p:cNvPr id="8" name="Text 6"/>
-          <p:cNvSpPr txBox="1"/>
-          <p:nvPr/>
-        </p:nvSpPr>
-        <p:spPr>
-          <a:xfrm>
-            <a:off x="6446520" y="1874520"/>
-            <a:ext cx="2057400" cy="1463040"/>
-          </a:xfrm>
-          <a:prstGeom prst="rect">
-            <a:avLst/>
-          </a:prstGeom>
-          <a:noFill/>
-          <a:ln/>
-        </p:spPr>
-        <p:txBody>
-          <a:bodyPr wrap="square" lIns="0" tIns="0" rIns="0" bIns="0" rtlCol="0" anchor="t"/>
-          <a:lstStyle/>
-          <a:p>
-            <a:pPr algn="ctr" indent="0" marL="0">
-              <a:buNone/>
-            </a:pPr>
-            <a:r>
-              <a:rPr lang="en-US" sz="1300" i="1" dirty="0">
-                <a:solidFill>
-                  <a:srgbClr val="EAF1F7"/>
-                </a:solidFill>
-              </a:rPr>
-              <a:t>Weltkarte mit leuchtenden Innovationszentren für fortschrittliche Robotik.</a:t>
-            </a:r>
-            <a:endParaRPr lang="en-US" sz="1300" dirty="0"/>
-          </a:p>
-        </p:txBody>
-      </p:sp>
-      <p:sp>
-        <p:nvSpPr>
-          <p:cNvPr id="9" name="Text 7"/>
-          <p:cNvSpPr txBox="1"/>
-          <p:nvPr/>
-        </p:nvSpPr>
-        <p:spPr>
-          <a:xfrm>
-            <a:off x="6217920" y="3566160"/>
-            <a:ext cx="2514600" cy="228600"/>
-          </a:xfrm>
-          <a:prstGeom prst="rect">
-            <a:avLst/>
-          </a:prstGeom>
-          <a:noFill/>
-          <a:ln/>
-        </p:spPr>
-        <p:txBody>
-          <a:bodyPr wrap="square" lIns="0" tIns="0" rIns="0" bIns="0" rtlCol="0" anchor="ctr"/>
-          <a:lstStyle/>
-          <a:p>
-            <a:pPr algn="ctr" indent="0" marL="0">
+            <a:pPr indent="0" marL="0">
               <a:buNone/>
             </a:pPr>
             <a:r>
@@ -6706,7 +6394,7 @@
                   <a:srgbClr val="5B7C99"/>
                 </a:solidFill>
               </a:rPr>
-              <a:t>Bildmotiv (Platzhalter)</a:t>
+              <a:t>Foto: Illustrationsfoto / Wikimedia Commons</a:t>
             </a:r>
             <a:endParaRPr lang="en-US" sz="1000" dirty="0"/>
           </a:p>
@@ -7432,43 +7120,40 @@
           </a:p>
         </p:txBody>
       </p:sp>
-      <p:sp>
-        <p:nvSpPr>
-          <p:cNvPr id="6" name="Bildplatzhalter"/>
-          <p:cNvSpPr/>
-          <p:nvPr/>
-        </p:nvSpPr>
-        <p:spPr>
-          <a:xfrm>
-            <a:off x="6217920" y="822960"/>
-            <a:ext cx="2514600" cy="2651760"/>
-          </a:xfrm>
-          <a:prstGeom prst="roundRect">
-            <a:avLst>
-              <a:gd name="adj" fmla="val 5455"/>
-            </a:avLst>
-          </a:prstGeom>
-          <a:solidFill>
-            <a:srgbClr val="12304D"/>
-          </a:solidFill>
-          <a:ln w="12700">
-            <a:solidFill>
-              <a:srgbClr val="12304D"/>
-            </a:solidFill>
-            <a:prstDash val="solid"/>
-          </a:ln>
-        </p:spPr>
-      </p:sp>
-      <p:sp>
-        <p:nvSpPr>
-          <p:cNvPr id="7" name="Text 5"/>
-          <p:cNvSpPr txBox="1"/>
-          <p:nvPr/>
-        </p:nvSpPr>
-        <p:spPr>
-          <a:xfrm>
-            <a:off x="6217920" y="960120"/>
-            <a:ext cx="2514600" cy="822960"/>
+      <p:pic>
+        <p:nvPicPr>
+          <p:cNvPr id="6" name="Foto" descr="Taktile Roboterfinger mit weichen Silikonkappen greifen behutsam ein Hühnerei.">    </p:cNvPr>
+          <p:cNvPicPr>
+            <a:picLocks noChangeAspect="1"/>
+          </p:cNvPicPr>
+          <p:nvPr/>
+        </p:nvPicPr>
+        <p:blipFill>
+          <a:blip r:embed="rId1"/>
+          <a:stretch>
+            <a:fillRect/>
+          </a:stretch>
+        </p:blipFill>
+        <p:spPr>
+          <a:xfrm>
+            <a:off x="6217920" y="457200"/>
+            <a:ext cx="2514600" cy="3291840"/>
+          </a:xfrm>
+          <a:prstGeom prst="rect">
+            <a:avLst/>
+          </a:prstGeom>
+        </p:spPr>
+      </p:pic>
+      <p:sp>
+        <p:nvSpPr>
+          <p:cNvPr id="7" name="Text 4"/>
+          <p:cNvSpPr txBox="1"/>
+          <p:nvPr/>
+        </p:nvSpPr>
+        <p:spPr>
+          <a:xfrm>
+            <a:off x="6217920" y="3822192"/>
+            <a:ext cx="2514600" cy="201168"/>
           </a:xfrm>
           <a:prstGeom prst="rect">
             <a:avLst/>
@@ -7480,82 +7165,7 @@
           <a:bodyPr wrap="square" lIns="0" tIns="0" rIns="0" bIns="0" rtlCol="0" anchor="ctr"/>
           <a:lstStyle/>
           <a:p>
-            <a:pPr algn="ctr" indent="0" marL="0">
-              <a:buNone/>
-            </a:pPr>
-            <a:r>
-              <a:rPr lang="en-US" sz="5400" b="1" dirty="0">
-                <a:solidFill>
-                  <a:srgbClr val="FF7A1A"/>
-                </a:solidFill>
-                <a:latin typeface="Cambria" pitchFamily="34" charset="0"/>
-                <a:ea typeface="Cambria" pitchFamily="34" charset="-122"/>
-                <a:cs typeface="Cambria" pitchFamily="34" charset="-120"/>
-              </a:rPr>
-              <a:t>19</a:t>
-            </a:r>
-            <a:endParaRPr lang="en-US" sz="5400" dirty="0"/>
-          </a:p>
-        </p:txBody>
-      </p:sp>
-      <p:sp>
-        <p:nvSpPr>
-          <p:cNvPr id="8" name="Text 6"/>
-          <p:cNvSpPr txBox="1"/>
-          <p:nvPr/>
-        </p:nvSpPr>
-        <p:spPr>
-          <a:xfrm>
-            <a:off x="6446520" y="1874520"/>
-            <a:ext cx="2057400" cy="1463040"/>
-          </a:xfrm>
-          <a:prstGeom prst="rect">
-            <a:avLst/>
-          </a:prstGeom>
-          <a:noFill/>
-          <a:ln/>
-        </p:spPr>
-        <p:txBody>
-          <a:bodyPr wrap="square" lIns="0" tIns="0" rIns="0" bIns="0" rtlCol="0" anchor="t"/>
-          <a:lstStyle/>
-          <a:p>
-            <a:pPr algn="ctr" indent="0" marL="0">
-              <a:buNone/>
-            </a:pPr>
-            <a:r>
-              <a:rPr lang="en-US" sz="1300" i="1" dirty="0">
-                <a:solidFill>
-                  <a:srgbClr val="EAF1F7"/>
-                </a:solidFill>
-              </a:rPr>
-              <a:t>Taktile Roboterfinger mit weichen Silikonkappen greifen behutsam ein Hühnerei.</a:t>
-            </a:r>
-            <a:endParaRPr lang="en-US" sz="1300" dirty="0"/>
-          </a:p>
-        </p:txBody>
-      </p:sp>
-      <p:sp>
-        <p:nvSpPr>
-          <p:cNvPr id="9" name="Text 7"/>
-          <p:cNvSpPr txBox="1"/>
-          <p:nvPr/>
-        </p:nvSpPr>
-        <p:spPr>
-          <a:xfrm>
-            <a:off x="6217920" y="3566160"/>
-            <a:ext cx="2514600" cy="228600"/>
-          </a:xfrm>
-          <a:prstGeom prst="rect">
-            <a:avLst/>
-          </a:prstGeom>
-          <a:noFill/>
-          <a:ln/>
-        </p:spPr>
-        <p:txBody>
-          <a:bodyPr wrap="square" lIns="0" tIns="0" rIns="0" bIns="0" rtlCol="0" anchor="ctr"/>
-          <a:lstStyle/>
-          <a:p>
-            <a:pPr algn="ctr" indent="0" marL="0">
+            <a:pPr indent="0" marL="0">
               <a:buNone/>
             </a:pPr>
             <a:r>
@@ -7564,7 +7174,7 @@
                   <a:srgbClr val="5B7C99"/>
                 </a:solidFill>
               </a:rPr>
-              <a:t>Bildmotiv (Platzhalter)</a:t>
+              <a:t>Foto: Illustrationsfoto / Wikimedia Commons</a:t>
             </a:r>
             <a:endParaRPr lang="en-US" sz="1000" dirty="0"/>
           </a:p>
@@ -8056,43 +7666,40 @@
           </a:p>
         </p:txBody>
       </p:sp>
-      <p:sp>
-        <p:nvSpPr>
-          <p:cNvPr id="6" name="Bildplatzhalter"/>
-          <p:cNvSpPr/>
-          <p:nvPr/>
-        </p:nvSpPr>
-        <p:spPr>
-          <a:xfrm>
-            <a:off x="6217920" y="822960"/>
-            <a:ext cx="2514600" cy="2651760"/>
-          </a:xfrm>
-          <a:prstGeom prst="roundRect">
-            <a:avLst>
-              <a:gd name="adj" fmla="val 5455"/>
-            </a:avLst>
-          </a:prstGeom>
-          <a:solidFill>
-            <a:srgbClr val="12304D"/>
-          </a:solidFill>
-          <a:ln w="12700">
-            <a:solidFill>
-              <a:srgbClr val="12304D"/>
-            </a:solidFill>
-            <a:prstDash val="solid"/>
-          </a:ln>
-        </p:spPr>
-      </p:sp>
-      <p:sp>
-        <p:nvSpPr>
-          <p:cNvPr id="7" name="Text 5"/>
-          <p:cNvSpPr txBox="1"/>
-          <p:nvPr/>
-        </p:nvSpPr>
-        <p:spPr>
-          <a:xfrm>
-            <a:off x="6217920" y="960120"/>
-            <a:ext cx="2514600" cy="822960"/>
+      <p:pic>
+        <p:nvPicPr>
+          <p:cNvPr id="6" name="Foto" descr="Sanfte Berührung zwischen einem menschlichen Arm und einem weich nachgebenden Roboterarm.">    </p:cNvPr>
+          <p:cNvPicPr>
+            <a:picLocks noChangeAspect="1"/>
+          </p:cNvPicPr>
+          <p:nvPr/>
+        </p:nvPicPr>
+        <p:blipFill>
+          <a:blip r:embed="rId1"/>
+          <a:stretch>
+            <a:fillRect/>
+          </a:stretch>
+        </p:blipFill>
+        <p:spPr>
+          <a:xfrm>
+            <a:off x="6217920" y="457200"/>
+            <a:ext cx="2514600" cy="3291840"/>
+          </a:xfrm>
+          <a:prstGeom prst="rect">
+            <a:avLst/>
+          </a:prstGeom>
+        </p:spPr>
+      </p:pic>
+      <p:sp>
+        <p:nvSpPr>
+          <p:cNvPr id="7" name="Text 4"/>
+          <p:cNvSpPr txBox="1"/>
+          <p:nvPr/>
+        </p:nvSpPr>
+        <p:spPr>
+          <a:xfrm>
+            <a:off x="6217920" y="3822192"/>
+            <a:ext cx="2514600" cy="201168"/>
           </a:xfrm>
           <a:prstGeom prst="rect">
             <a:avLst/>
@@ -8104,82 +7711,7 @@
           <a:bodyPr wrap="square" lIns="0" tIns="0" rIns="0" bIns="0" rtlCol="0" anchor="ctr"/>
           <a:lstStyle/>
           <a:p>
-            <a:pPr algn="ctr" indent="0" marL="0">
-              <a:buNone/>
-            </a:pPr>
-            <a:r>
-              <a:rPr lang="en-US" sz="5400" b="1" dirty="0">
-                <a:solidFill>
-                  <a:srgbClr val="FF7A1A"/>
-                </a:solidFill>
-                <a:latin typeface="Cambria" pitchFamily="34" charset="0"/>
-                <a:ea typeface="Cambria" pitchFamily="34" charset="-122"/>
-                <a:cs typeface="Cambria" pitchFamily="34" charset="-120"/>
-              </a:rPr>
-              <a:t>21</a:t>
-            </a:r>
-            <a:endParaRPr lang="en-US" sz="5400" dirty="0"/>
-          </a:p>
-        </p:txBody>
-      </p:sp>
-      <p:sp>
-        <p:nvSpPr>
-          <p:cNvPr id="8" name="Text 6"/>
-          <p:cNvSpPr txBox="1"/>
-          <p:nvPr/>
-        </p:nvSpPr>
-        <p:spPr>
-          <a:xfrm>
-            <a:off x="6446520" y="1874520"/>
-            <a:ext cx="2057400" cy="1463040"/>
-          </a:xfrm>
-          <a:prstGeom prst="rect">
-            <a:avLst/>
-          </a:prstGeom>
-          <a:noFill/>
-          <a:ln/>
-        </p:spPr>
-        <p:txBody>
-          <a:bodyPr wrap="square" lIns="0" tIns="0" rIns="0" bIns="0" rtlCol="0" anchor="t"/>
-          <a:lstStyle/>
-          <a:p>
-            <a:pPr algn="ctr" indent="0" marL="0">
-              <a:buNone/>
-            </a:pPr>
-            <a:r>
-              <a:rPr lang="en-US" sz="1300" i="1" dirty="0">
-                <a:solidFill>
-                  <a:srgbClr val="EAF1F7"/>
-                </a:solidFill>
-              </a:rPr>
-              <a:t>Sanfte Berührung zwischen einem menschlichen Arm und einem weich nachgebenden Roboterarm.</a:t>
-            </a:r>
-            <a:endParaRPr lang="en-US" sz="1300" dirty="0"/>
-          </a:p>
-        </p:txBody>
-      </p:sp>
-      <p:sp>
-        <p:nvSpPr>
-          <p:cNvPr id="9" name="Text 7"/>
-          <p:cNvSpPr txBox="1"/>
-          <p:nvPr/>
-        </p:nvSpPr>
-        <p:spPr>
-          <a:xfrm>
-            <a:off x="6217920" y="3566160"/>
-            <a:ext cx="2514600" cy="228600"/>
-          </a:xfrm>
-          <a:prstGeom prst="rect">
-            <a:avLst/>
-          </a:prstGeom>
-          <a:noFill/>
-          <a:ln/>
-        </p:spPr>
-        <p:txBody>
-          <a:bodyPr wrap="square" lIns="0" tIns="0" rIns="0" bIns="0" rtlCol="0" anchor="ctr"/>
-          <a:lstStyle/>
-          <a:p>
-            <a:pPr algn="ctr" indent="0" marL="0">
+            <a:pPr indent="0" marL="0">
               <a:buNone/>
             </a:pPr>
             <a:r>
@@ -8188,7 +7720,7 @@
                   <a:srgbClr val="5B7C99"/>
                 </a:solidFill>
               </a:rPr>
-              <a:t>Bildmotiv (Platzhalter)</a:t>
+              <a:t>Foto: Illustrationsfoto / Wikimedia Commons</a:t>
             </a:r>
             <a:endParaRPr lang="en-US" sz="1000" dirty="0"/>
           </a:p>
@@ -8368,43 +7900,40 @@
           </a:p>
         </p:txBody>
       </p:sp>
-      <p:sp>
-        <p:nvSpPr>
-          <p:cNvPr id="6" name="Bildplatzhalter"/>
-          <p:cNvSpPr/>
-          <p:nvPr/>
-        </p:nvSpPr>
-        <p:spPr>
-          <a:xfrm>
-            <a:off x="6217920" y="822960"/>
-            <a:ext cx="2514600" cy="2651760"/>
-          </a:xfrm>
-          <a:prstGeom prst="roundRect">
-            <a:avLst>
-              <a:gd name="adj" fmla="val 5455"/>
-            </a:avLst>
-          </a:prstGeom>
-          <a:solidFill>
-            <a:srgbClr val="12304D"/>
-          </a:solidFill>
-          <a:ln w="12700">
-            <a:solidFill>
-              <a:srgbClr val="12304D"/>
-            </a:solidFill>
-            <a:prstDash val="solid"/>
-          </a:ln>
-        </p:spPr>
-      </p:sp>
-      <p:sp>
-        <p:nvSpPr>
-          <p:cNvPr id="7" name="Text 5"/>
-          <p:cNvSpPr txBox="1"/>
-          <p:nvPr/>
-        </p:nvSpPr>
-        <p:spPr>
-          <a:xfrm>
-            <a:off x="6217920" y="960120"/>
-            <a:ext cx="2514600" cy="822960"/>
+      <p:pic>
+        <p:nvPicPr>
+          <p:cNvPr id="6" name="Foto" descr="Querschnitt eines Elektromotors und ein modulares Akkupaket.">    </p:cNvPr>
+          <p:cNvPicPr>
+            <a:picLocks noChangeAspect="1"/>
+          </p:cNvPicPr>
+          <p:nvPr/>
+        </p:nvPicPr>
+        <p:blipFill>
+          <a:blip r:embed="rId1"/>
+          <a:stretch>
+            <a:fillRect/>
+          </a:stretch>
+        </p:blipFill>
+        <p:spPr>
+          <a:xfrm>
+            <a:off x="6217920" y="457200"/>
+            <a:ext cx="2514600" cy="3291840"/>
+          </a:xfrm>
+          <a:prstGeom prst="rect">
+            <a:avLst/>
+          </a:prstGeom>
+        </p:spPr>
+      </p:pic>
+      <p:sp>
+        <p:nvSpPr>
+          <p:cNvPr id="7" name="Text 4"/>
+          <p:cNvSpPr txBox="1"/>
+          <p:nvPr/>
+        </p:nvSpPr>
+        <p:spPr>
+          <a:xfrm>
+            <a:off x="6217920" y="3822192"/>
+            <a:ext cx="2514600" cy="201168"/>
           </a:xfrm>
           <a:prstGeom prst="rect">
             <a:avLst/>
@@ -8416,82 +7945,7 @@
           <a:bodyPr wrap="square" lIns="0" tIns="0" rIns="0" bIns="0" rtlCol="0" anchor="ctr"/>
           <a:lstStyle/>
           <a:p>
-            <a:pPr algn="ctr" indent="0" marL="0">
-              <a:buNone/>
-            </a:pPr>
-            <a:r>
-              <a:rPr lang="en-US" sz="5400" b="1" dirty="0">
-                <a:solidFill>
-                  <a:srgbClr val="FF7A1A"/>
-                </a:solidFill>
-                <a:latin typeface="Cambria" pitchFamily="34" charset="0"/>
-                <a:ea typeface="Cambria" pitchFamily="34" charset="-122"/>
-                <a:cs typeface="Cambria" pitchFamily="34" charset="-120"/>
-              </a:rPr>
-              <a:t>22</a:t>
-            </a:r>
-            <a:endParaRPr lang="en-US" sz="5400" dirty="0"/>
-          </a:p>
-        </p:txBody>
-      </p:sp>
-      <p:sp>
-        <p:nvSpPr>
-          <p:cNvPr id="8" name="Text 6"/>
-          <p:cNvSpPr txBox="1"/>
-          <p:nvPr/>
-        </p:nvSpPr>
-        <p:spPr>
-          <a:xfrm>
-            <a:off x="6446520" y="1874520"/>
-            <a:ext cx="2057400" cy="1463040"/>
-          </a:xfrm>
-          <a:prstGeom prst="rect">
-            <a:avLst/>
-          </a:prstGeom>
-          <a:noFill/>
-          <a:ln/>
-        </p:spPr>
-        <p:txBody>
-          <a:bodyPr wrap="square" lIns="0" tIns="0" rIns="0" bIns="0" rtlCol="0" anchor="t"/>
-          <a:lstStyle/>
-          <a:p>
-            <a:pPr algn="ctr" indent="0" marL="0">
-              <a:buNone/>
-            </a:pPr>
-            <a:r>
-              <a:rPr lang="en-US" sz="1300" i="1" dirty="0">
-                <a:solidFill>
-                  <a:srgbClr val="EAF1F7"/>
-                </a:solidFill>
-              </a:rPr>
-              <a:t>Querschnitt eines Elektromotors und ein modulares Akkupaket.</a:t>
-            </a:r>
-            <a:endParaRPr lang="en-US" sz="1300" dirty="0"/>
-          </a:p>
-        </p:txBody>
-      </p:sp>
-      <p:sp>
-        <p:nvSpPr>
-          <p:cNvPr id="9" name="Text 7"/>
-          <p:cNvSpPr txBox="1"/>
-          <p:nvPr/>
-        </p:nvSpPr>
-        <p:spPr>
-          <a:xfrm>
-            <a:off x="6217920" y="3566160"/>
-            <a:ext cx="2514600" cy="228600"/>
-          </a:xfrm>
-          <a:prstGeom prst="rect">
-            <a:avLst/>
-          </a:prstGeom>
-          <a:noFill/>
-          <a:ln/>
-        </p:spPr>
-        <p:txBody>
-          <a:bodyPr wrap="square" lIns="0" tIns="0" rIns="0" bIns="0" rtlCol="0" anchor="ctr"/>
-          <a:lstStyle/>
-          <a:p>
-            <a:pPr algn="ctr" indent="0" marL="0">
+            <a:pPr indent="0" marL="0">
               <a:buNone/>
             </a:pPr>
             <a:r>
@@ -8500,7 +7954,7 @@
                   <a:srgbClr val="5B7C99"/>
                 </a:solidFill>
               </a:rPr>
-              <a:t>Bildmotiv (Platzhalter)</a:t>
+              <a:t>Foto: Illustrationsfoto / Wikimedia Commons</a:t>
             </a:r>
             <a:endParaRPr lang="en-US" sz="1000" dirty="0"/>
           </a:p>
@@ -8680,43 +8134,40 @@
           </a:p>
         </p:txBody>
       </p:sp>
-      <p:sp>
-        <p:nvSpPr>
-          <p:cNvPr id="6" name="Bildplatzhalter"/>
-          <p:cNvSpPr/>
-          <p:nvPr/>
-        </p:nvSpPr>
-        <p:spPr>
-          <a:xfrm>
-            <a:off x="6217920" y="822960"/>
-            <a:ext cx="2514600" cy="2651760"/>
-          </a:xfrm>
-          <a:prstGeom prst="roundRect">
-            <a:avLst>
-              <a:gd name="adj" fmla="val 5455"/>
-            </a:avLst>
-          </a:prstGeom>
-          <a:solidFill>
-            <a:srgbClr val="12304D"/>
-          </a:solidFill>
-          <a:ln w="12700">
-            <a:solidFill>
-              <a:srgbClr val="12304D"/>
-            </a:solidFill>
-            <a:prstDash val="solid"/>
-          </a:ln>
-        </p:spPr>
-      </p:sp>
-      <p:sp>
-        <p:nvSpPr>
-          <p:cNvPr id="7" name="Text 5"/>
-          <p:cNvSpPr txBox="1"/>
-          <p:nvPr/>
-        </p:nvSpPr>
-        <p:spPr>
-          <a:xfrm>
-            <a:off x="6217920" y="960120"/>
-            <a:ext cx="2514600" cy="822960"/>
+      <p:pic>
+        <p:nvPicPr>
+          <p:cNvPr id="6" name="Foto" descr="3D-Tiefenkarte eines Wohnraums mit erkannten Objekten und Hindernissen.">    </p:cNvPr>
+          <p:cNvPicPr>
+            <a:picLocks noChangeAspect="1"/>
+          </p:cNvPicPr>
+          <p:nvPr/>
+        </p:nvPicPr>
+        <p:blipFill>
+          <a:blip r:embed="rId1"/>
+          <a:stretch>
+            <a:fillRect/>
+          </a:stretch>
+        </p:blipFill>
+        <p:spPr>
+          <a:xfrm>
+            <a:off x="6217920" y="457200"/>
+            <a:ext cx="2514600" cy="3291840"/>
+          </a:xfrm>
+          <a:prstGeom prst="rect">
+            <a:avLst/>
+          </a:prstGeom>
+        </p:spPr>
+      </p:pic>
+      <p:sp>
+        <p:nvSpPr>
+          <p:cNvPr id="7" name="Text 4"/>
+          <p:cNvSpPr txBox="1"/>
+          <p:nvPr/>
+        </p:nvSpPr>
+        <p:spPr>
+          <a:xfrm>
+            <a:off x="6217920" y="3822192"/>
+            <a:ext cx="2514600" cy="201168"/>
           </a:xfrm>
           <a:prstGeom prst="rect">
             <a:avLst/>
@@ -8728,82 +8179,7 @@
           <a:bodyPr wrap="square" lIns="0" tIns="0" rIns="0" bIns="0" rtlCol="0" anchor="ctr"/>
           <a:lstStyle/>
           <a:p>
-            <a:pPr algn="ctr" indent="0" marL="0">
-              <a:buNone/>
-            </a:pPr>
-            <a:r>
-              <a:rPr lang="en-US" sz="5400" b="1" dirty="0">
-                <a:solidFill>
-                  <a:srgbClr val="FF7A1A"/>
-                </a:solidFill>
-                <a:latin typeface="Cambria" pitchFamily="34" charset="0"/>
-                <a:ea typeface="Cambria" pitchFamily="34" charset="-122"/>
-                <a:cs typeface="Cambria" pitchFamily="34" charset="-120"/>
-              </a:rPr>
-              <a:t>23</a:t>
-            </a:r>
-            <a:endParaRPr lang="en-US" sz="5400" dirty="0"/>
-          </a:p>
-        </p:txBody>
-      </p:sp>
-      <p:sp>
-        <p:nvSpPr>
-          <p:cNvPr id="8" name="Text 6"/>
-          <p:cNvSpPr txBox="1"/>
-          <p:nvPr/>
-        </p:nvSpPr>
-        <p:spPr>
-          <a:xfrm>
-            <a:off x="6446520" y="1874520"/>
-            <a:ext cx="2057400" cy="1463040"/>
-          </a:xfrm>
-          <a:prstGeom prst="rect">
-            <a:avLst/>
-          </a:prstGeom>
-          <a:noFill/>
-          <a:ln/>
-        </p:spPr>
-        <p:txBody>
-          <a:bodyPr wrap="square" lIns="0" tIns="0" rIns="0" bIns="0" rtlCol="0" anchor="t"/>
-          <a:lstStyle/>
-          <a:p>
-            <a:pPr algn="ctr" indent="0" marL="0">
-              <a:buNone/>
-            </a:pPr>
-            <a:r>
-              <a:rPr lang="en-US" sz="1300" i="1" dirty="0">
-                <a:solidFill>
-                  <a:srgbClr val="EAF1F7"/>
-                </a:solidFill>
-              </a:rPr>
-              <a:t>3D-Tiefenkarte eines Wohnraums mit erkannten Objekten und Hindernissen.</a:t>
-            </a:r>
-            <a:endParaRPr lang="en-US" sz="1300" dirty="0"/>
-          </a:p>
-        </p:txBody>
-      </p:sp>
-      <p:sp>
-        <p:nvSpPr>
-          <p:cNvPr id="9" name="Text 7"/>
-          <p:cNvSpPr txBox="1"/>
-          <p:nvPr/>
-        </p:nvSpPr>
-        <p:spPr>
-          <a:xfrm>
-            <a:off x="6217920" y="3566160"/>
-            <a:ext cx="2514600" cy="228600"/>
-          </a:xfrm>
-          <a:prstGeom prst="rect">
-            <a:avLst/>
-          </a:prstGeom>
-          <a:noFill/>
-          <a:ln/>
-        </p:spPr>
-        <p:txBody>
-          <a:bodyPr wrap="square" lIns="0" tIns="0" rIns="0" bIns="0" rtlCol="0" anchor="ctr"/>
-          <a:lstStyle/>
-          <a:p>
-            <a:pPr algn="ctr" indent="0" marL="0">
+            <a:pPr indent="0" marL="0">
               <a:buNone/>
             </a:pPr>
             <a:r>
@@ -8812,7 +8188,7 @@
                   <a:srgbClr val="5B7C99"/>
                 </a:solidFill>
               </a:rPr>
-              <a:t>Bildmotiv (Platzhalter)</a:t>
+              <a:t>Foto: Illustrationsfoto / Wikimedia Commons</a:t>
             </a:r>
             <a:endParaRPr lang="en-US" sz="1000" dirty="0"/>
           </a:p>
@@ -9653,43 +9029,40 @@
           </a:p>
         </p:txBody>
       </p:sp>
-      <p:sp>
-        <p:nvSpPr>
-          <p:cNvPr id="6" name="Bildplatzhalter"/>
-          <p:cNvSpPr/>
-          <p:nvPr/>
-        </p:nvSpPr>
-        <p:spPr>
-          <a:xfrm>
-            <a:off x="6217920" y="822960"/>
-            <a:ext cx="2514600" cy="2651760"/>
-          </a:xfrm>
-          <a:prstGeom prst="roundRect">
-            <a:avLst>
-              <a:gd name="adj" fmla="val 5455"/>
-            </a:avLst>
-          </a:prstGeom>
-          <a:solidFill>
-            <a:srgbClr val="12304D"/>
-          </a:solidFill>
-          <a:ln w="12700">
-            <a:solidFill>
-              <a:srgbClr val="12304D"/>
-            </a:solidFill>
-            <a:prstDash val="solid"/>
-          </a:ln>
-        </p:spPr>
-      </p:sp>
-      <p:sp>
-        <p:nvSpPr>
-          <p:cNvPr id="7" name="Text 5"/>
-          <p:cNvSpPr txBox="1"/>
-          <p:nvPr/>
-        </p:nvSpPr>
-        <p:spPr>
-          <a:xfrm>
-            <a:off x="6217920" y="960120"/>
-            <a:ext cx="2514600" cy="822960"/>
+      <p:pic>
+        <p:nvPicPr>
+          <p:cNvPr id="6" name="Foto" descr="Roboter stützt sanft eine ältere Person beim Gehen im Flur eines Seniorenheims.">    </p:cNvPr>
+          <p:cNvPicPr>
+            <a:picLocks noChangeAspect="1"/>
+          </p:cNvPicPr>
+          <p:nvPr/>
+        </p:nvPicPr>
+        <p:blipFill>
+          <a:blip r:embed="rId1"/>
+          <a:stretch>
+            <a:fillRect/>
+          </a:stretch>
+        </p:blipFill>
+        <p:spPr>
+          <a:xfrm>
+            <a:off x="6217920" y="457200"/>
+            <a:ext cx="2514600" cy="3291840"/>
+          </a:xfrm>
+          <a:prstGeom prst="rect">
+            <a:avLst/>
+          </a:prstGeom>
+        </p:spPr>
+      </p:pic>
+      <p:sp>
+        <p:nvSpPr>
+          <p:cNvPr id="7" name="Text 4"/>
+          <p:cNvSpPr txBox="1"/>
+          <p:nvPr/>
+        </p:nvSpPr>
+        <p:spPr>
+          <a:xfrm>
+            <a:off x="6217920" y="3822192"/>
+            <a:ext cx="2514600" cy="201168"/>
           </a:xfrm>
           <a:prstGeom prst="rect">
             <a:avLst/>
@@ -9701,82 +9074,7 @@
           <a:bodyPr wrap="square" lIns="0" tIns="0" rIns="0" bIns="0" rtlCol="0" anchor="ctr"/>
           <a:lstStyle/>
           <a:p>
-            <a:pPr algn="ctr" indent="0" marL="0">
-              <a:buNone/>
-            </a:pPr>
-            <a:r>
-              <a:rPr lang="en-US" sz="5400" b="1" dirty="0">
-                <a:solidFill>
-                  <a:srgbClr val="FF7A1A"/>
-                </a:solidFill>
-                <a:latin typeface="Cambria" pitchFamily="34" charset="0"/>
-                <a:ea typeface="Cambria" pitchFamily="34" charset="-122"/>
-                <a:cs typeface="Cambria" pitchFamily="34" charset="-120"/>
-              </a:rPr>
-              <a:t>26</a:t>
-            </a:r>
-            <a:endParaRPr lang="en-US" sz="5400" dirty="0"/>
-          </a:p>
-        </p:txBody>
-      </p:sp>
-      <p:sp>
-        <p:nvSpPr>
-          <p:cNvPr id="8" name="Text 6"/>
-          <p:cNvSpPr txBox="1"/>
-          <p:nvPr/>
-        </p:nvSpPr>
-        <p:spPr>
-          <a:xfrm>
-            <a:off x="6446520" y="1874520"/>
-            <a:ext cx="2057400" cy="1463040"/>
-          </a:xfrm>
-          <a:prstGeom prst="rect">
-            <a:avLst/>
-          </a:prstGeom>
-          <a:noFill/>
-          <a:ln/>
-        </p:spPr>
-        <p:txBody>
-          <a:bodyPr wrap="square" lIns="0" tIns="0" rIns="0" bIns="0" rtlCol="0" anchor="t"/>
-          <a:lstStyle/>
-          <a:p>
-            <a:pPr algn="ctr" indent="0" marL="0">
-              <a:buNone/>
-            </a:pPr>
-            <a:r>
-              <a:rPr lang="en-US" sz="1300" i="1" dirty="0">
-                <a:solidFill>
-                  <a:srgbClr val="EAF1F7"/>
-                </a:solidFill>
-              </a:rPr>
-              <a:t>Roboter stützt sanft eine ältere Person beim Gehen im Flur eines Seniorenheims.</a:t>
-            </a:r>
-            <a:endParaRPr lang="en-US" sz="1300" dirty="0"/>
-          </a:p>
-        </p:txBody>
-      </p:sp>
-      <p:sp>
-        <p:nvSpPr>
-          <p:cNvPr id="9" name="Text 7"/>
-          <p:cNvSpPr txBox="1"/>
-          <p:nvPr/>
-        </p:nvSpPr>
-        <p:spPr>
-          <a:xfrm>
-            <a:off x="6217920" y="3566160"/>
-            <a:ext cx="2514600" cy="228600"/>
-          </a:xfrm>
-          <a:prstGeom prst="rect">
-            <a:avLst/>
-          </a:prstGeom>
-          <a:noFill/>
-          <a:ln/>
-        </p:spPr>
-        <p:txBody>
-          <a:bodyPr wrap="square" lIns="0" tIns="0" rIns="0" bIns="0" rtlCol="0" anchor="ctr"/>
-          <a:lstStyle/>
-          <a:p>
-            <a:pPr algn="ctr" indent="0" marL="0">
+            <a:pPr indent="0" marL="0">
               <a:buNone/>
             </a:pPr>
             <a:r>
@@ -9785,7 +9083,7 @@
                   <a:srgbClr val="5B7C99"/>
                 </a:solidFill>
               </a:rPr>
-              <a:t>Bildmotiv (Platzhalter)</a:t>
+              <a:t>Foto: Illustrationsfoto / Wikimedia Commons</a:t>
             </a:r>
             <a:endParaRPr lang="en-US" sz="1000" dirty="0"/>
           </a:p>
@@ -10277,43 +9575,40 @@
           </a:p>
         </p:txBody>
       </p:sp>
-      <p:sp>
-        <p:nvSpPr>
-          <p:cNvPr id="6" name="Bildplatzhalter"/>
-          <p:cNvSpPr/>
-          <p:nvPr/>
-        </p:nvSpPr>
-        <p:spPr>
-          <a:xfrm>
-            <a:off x="6217920" y="822960"/>
-            <a:ext cx="2514600" cy="2651760"/>
-          </a:xfrm>
-          <a:prstGeom prst="roundRect">
-            <a:avLst>
-              <a:gd name="adj" fmla="val 5455"/>
-            </a:avLst>
-          </a:prstGeom>
-          <a:solidFill>
-            <a:srgbClr val="12304D"/>
-          </a:solidFill>
-          <a:ln w="12700">
-            <a:solidFill>
-              <a:srgbClr val="12304D"/>
-            </a:solidFill>
-            <a:prstDash val="solid"/>
-          </a:ln>
-        </p:spPr>
-      </p:sp>
-      <p:sp>
-        <p:nvSpPr>
-          <p:cNvPr id="7" name="Text 5"/>
-          <p:cNvSpPr txBox="1"/>
-          <p:nvPr/>
-        </p:nvSpPr>
-        <p:spPr>
-          <a:xfrm>
-            <a:off x="6217920" y="960120"/>
-            <a:ext cx="2514600" cy="822960"/>
+      <p:pic>
+        <p:nvPicPr>
+          <p:cNvPr id="6" name="Foto" descr="Ein digitales Schloss-Symbol vor einem Wohnzimmer-Hintergrund für Datenschutz.">    </p:cNvPr>
+          <p:cNvPicPr>
+            <a:picLocks noChangeAspect="1"/>
+          </p:cNvPicPr>
+          <p:nvPr/>
+        </p:nvPicPr>
+        <p:blipFill>
+          <a:blip r:embed="rId1"/>
+          <a:stretch>
+            <a:fillRect/>
+          </a:stretch>
+        </p:blipFill>
+        <p:spPr>
+          <a:xfrm>
+            <a:off x="6217920" y="457200"/>
+            <a:ext cx="2514600" cy="3291840"/>
+          </a:xfrm>
+          <a:prstGeom prst="rect">
+            <a:avLst/>
+          </a:prstGeom>
+        </p:spPr>
+      </p:pic>
+      <p:sp>
+        <p:nvSpPr>
+          <p:cNvPr id="7" name="Text 4"/>
+          <p:cNvSpPr txBox="1"/>
+          <p:nvPr/>
+        </p:nvSpPr>
+        <p:spPr>
+          <a:xfrm>
+            <a:off x="6217920" y="3822192"/>
+            <a:ext cx="2514600" cy="201168"/>
           </a:xfrm>
           <a:prstGeom prst="rect">
             <a:avLst/>
@@ -10325,82 +9620,7 @@
           <a:bodyPr wrap="square" lIns="0" tIns="0" rIns="0" bIns="0" rtlCol="0" anchor="ctr"/>
           <a:lstStyle/>
           <a:p>
-            <a:pPr algn="ctr" indent="0" marL="0">
-              <a:buNone/>
-            </a:pPr>
-            <a:r>
-              <a:rPr lang="en-US" sz="5400" b="1" dirty="0">
-                <a:solidFill>
-                  <a:srgbClr val="FF7A1A"/>
-                </a:solidFill>
-                <a:latin typeface="Cambria" pitchFamily="34" charset="0"/>
-                <a:ea typeface="Cambria" pitchFamily="34" charset="-122"/>
-                <a:cs typeface="Cambria" pitchFamily="34" charset="-120"/>
-              </a:rPr>
-              <a:t>28</a:t>
-            </a:r>
-            <a:endParaRPr lang="en-US" sz="5400" dirty="0"/>
-          </a:p>
-        </p:txBody>
-      </p:sp>
-      <p:sp>
-        <p:nvSpPr>
-          <p:cNvPr id="8" name="Text 6"/>
-          <p:cNvSpPr txBox="1"/>
-          <p:nvPr/>
-        </p:nvSpPr>
-        <p:spPr>
-          <a:xfrm>
-            <a:off x="6446520" y="1874520"/>
-            <a:ext cx="2057400" cy="1463040"/>
-          </a:xfrm>
-          <a:prstGeom prst="rect">
-            <a:avLst/>
-          </a:prstGeom>
-          <a:noFill/>
-          <a:ln/>
-        </p:spPr>
-        <p:txBody>
-          <a:bodyPr wrap="square" lIns="0" tIns="0" rIns="0" bIns="0" rtlCol="0" anchor="t"/>
-          <a:lstStyle/>
-          <a:p>
-            <a:pPr algn="ctr" indent="0" marL="0">
-              <a:buNone/>
-            </a:pPr>
-            <a:r>
-              <a:rPr lang="en-US" sz="1300" i="1" dirty="0">
-                <a:solidFill>
-                  <a:srgbClr val="EAF1F7"/>
-                </a:solidFill>
-              </a:rPr>
-              <a:t>Ein digitales Schloss-Symbol vor einem Wohnzimmer-Hintergrund für Datenschutz.</a:t>
-            </a:r>
-            <a:endParaRPr lang="en-US" sz="1300" dirty="0"/>
-          </a:p>
-        </p:txBody>
-      </p:sp>
-      <p:sp>
-        <p:nvSpPr>
-          <p:cNvPr id="9" name="Text 7"/>
-          <p:cNvSpPr txBox="1"/>
-          <p:nvPr/>
-        </p:nvSpPr>
-        <p:spPr>
-          <a:xfrm>
-            <a:off x="6217920" y="3566160"/>
-            <a:ext cx="2514600" cy="228600"/>
-          </a:xfrm>
-          <a:prstGeom prst="rect">
-            <a:avLst/>
-          </a:prstGeom>
-          <a:noFill/>
-          <a:ln/>
-        </p:spPr>
-        <p:txBody>
-          <a:bodyPr wrap="square" lIns="0" tIns="0" rIns="0" bIns="0" rtlCol="0" anchor="ctr"/>
-          <a:lstStyle/>
-          <a:p>
-            <a:pPr algn="ctr" indent="0" marL="0">
+            <a:pPr indent="0" marL="0">
               <a:buNone/>
             </a:pPr>
             <a:r>
@@ -10409,7 +9629,7 @@
                   <a:srgbClr val="5B7C99"/>
                 </a:solidFill>
               </a:rPr>
-              <a:t>Bildmotiv (Platzhalter)</a:t>
+              <a:t>Foto: Illustrationsfoto / Wikimedia Commons</a:t>
             </a:r>
             <a:endParaRPr lang="en-US" sz="1000" dirty="0"/>
           </a:p>
@@ -10823,43 +10043,40 @@
           </a:p>
         </p:txBody>
       </p:sp>
-      <p:sp>
-        <p:nvSpPr>
-          <p:cNvPr id="6" name="Bildplatzhalter"/>
-          <p:cNvSpPr/>
-          <p:nvPr/>
-        </p:nvSpPr>
-        <p:spPr>
-          <a:xfrm>
-            <a:off x="6217920" y="822960"/>
-            <a:ext cx="2514600" cy="2651760"/>
-          </a:xfrm>
-          <a:prstGeom prst="roundRect">
-            <a:avLst>
-              <a:gd name="adj" fmla="val 5455"/>
-            </a:avLst>
-          </a:prstGeom>
-          <a:solidFill>
-            <a:srgbClr val="12304D"/>
-          </a:solidFill>
-          <a:ln w="12700">
-            <a:solidFill>
-              <a:srgbClr val="12304D"/>
-            </a:solidFill>
-            <a:prstDash val="solid"/>
-          </a:ln>
-        </p:spPr>
-      </p:sp>
-      <p:sp>
-        <p:nvSpPr>
-          <p:cNvPr id="7" name="Text 5"/>
-          <p:cNvSpPr txBox="1"/>
-          <p:nvPr/>
-        </p:nvSpPr>
-        <p:spPr>
-          <a:xfrm>
-            <a:off x="6217920" y="960120"/>
-            <a:ext cx="2514600" cy="822960"/>
+      <p:pic>
+        <p:nvPicPr>
+          <p:cNvPr id="6" name="Foto" descr="Ingenieure prüfen neue Materialien und Batterien im Entwicklungszentrum.">    </p:cNvPr>
+          <p:cNvPicPr>
+            <a:picLocks noChangeAspect="1"/>
+          </p:cNvPicPr>
+          <p:nvPr/>
+        </p:nvPicPr>
+        <p:blipFill>
+          <a:blip r:embed="rId1"/>
+          <a:stretch>
+            <a:fillRect/>
+          </a:stretch>
+        </p:blipFill>
+        <p:spPr>
+          <a:xfrm>
+            <a:off x="6217920" y="457200"/>
+            <a:ext cx="2514600" cy="3291840"/>
+          </a:xfrm>
+          <a:prstGeom prst="rect">
+            <a:avLst/>
+          </a:prstGeom>
+        </p:spPr>
+      </p:pic>
+      <p:sp>
+        <p:nvSpPr>
+          <p:cNvPr id="7" name="Text 4"/>
+          <p:cNvSpPr txBox="1"/>
+          <p:nvPr/>
+        </p:nvSpPr>
+        <p:spPr>
+          <a:xfrm>
+            <a:off x="6217920" y="3822192"/>
+            <a:ext cx="2514600" cy="201168"/>
           </a:xfrm>
           <a:prstGeom prst="rect">
             <a:avLst/>
@@ -10871,82 +10088,7 @@
           <a:bodyPr wrap="square" lIns="0" tIns="0" rIns="0" bIns="0" rtlCol="0" anchor="ctr"/>
           <a:lstStyle/>
           <a:p>
-            <a:pPr algn="ctr" indent="0" marL="0">
-              <a:buNone/>
-            </a:pPr>
-            <a:r>
-              <a:rPr lang="en-US" sz="5400" b="1" dirty="0">
-                <a:solidFill>
-                  <a:srgbClr val="FF7A1A"/>
-                </a:solidFill>
-                <a:latin typeface="Cambria" pitchFamily="34" charset="0"/>
-                <a:ea typeface="Cambria" pitchFamily="34" charset="-122"/>
-                <a:cs typeface="Cambria" pitchFamily="34" charset="-120"/>
-              </a:rPr>
-              <a:t>29</a:t>
-            </a:r>
-            <a:endParaRPr lang="en-US" sz="5400" dirty="0"/>
-          </a:p>
-        </p:txBody>
-      </p:sp>
-      <p:sp>
-        <p:nvSpPr>
-          <p:cNvPr id="8" name="Text 6"/>
-          <p:cNvSpPr txBox="1"/>
-          <p:nvPr/>
-        </p:nvSpPr>
-        <p:spPr>
-          <a:xfrm>
-            <a:off x="6446520" y="1874520"/>
-            <a:ext cx="2057400" cy="1463040"/>
-          </a:xfrm>
-          <a:prstGeom prst="rect">
-            <a:avLst/>
-          </a:prstGeom>
-          <a:noFill/>
-          <a:ln/>
-        </p:spPr>
-        <p:txBody>
-          <a:bodyPr wrap="square" lIns="0" tIns="0" rIns="0" bIns="0" rtlCol="0" anchor="t"/>
-          <a:lstStyle/>
-          <a:p>
-            <a:pPr algn="ctr" indent="0" marL="0">
-              <a:buNone/>
-            </a:pPr>
-            <a:r>
-              <a:rPr lang="en-US" sz="1300" i="1" dirty="0">
-                <a:solidFill>
-                  <a:srgbClr val="EAF1F7"/>
-                </a:solidFill>
-              </a:rPr>
-              <a:t>Ingenieure prüfen neue Materialien und Batterien im Entwicklungszentrum.</a:t>
-            </a:r>
-            <a:endParaRPr lang="en-US" sz="1300" dirty="0"/>
-          </a:p>
-        </p:txBody>
-      </p:sp>
-      <p:sp>
-        <p:nvSpPr>
-          <p:cNvPr id="9" name="Text 7"/>
-          <p:cNvSpPr txBox="1"/>
-          <p:nvPr/>
-        </p:nvSpPr>
-        <p:spPr>
-          <a:xfrm>
-            <a:off x="6217920" y="3566160"/>
-            <a:ext cx="2514600" cy="228600"/>
-          </a:xfrm>
-          <a:prstGeom prst="rect">
-            <a:avLst/>
-          </a:prstGeom>
-          <a:noFill/>
-          <a:ln/>
-        </p:spPr>
-        <p:txBody>
-          <a:bodyPr wrap="square" lIns="0" tIns="0" rIns="0" bIns="0" rtlCol="0" anchor="ctr"/>
-          <a:lstStyle/>
-          <a:p>
-            <a:pPr algn="ctr" indent="0" marL="0">
+            <a:pPr indent="0" marL="0">
               <a:buNone/>
             </a:pPr>
             <a:r>
@@ -10955,7 +10097,7 @@
                   <a:srgbClr val="5B7C99"/>
                 </a:solidFill>
               </a:rPr>
-              <a:t>Bildmotiv (Platzhalter)</a:t>
+              <a:t>Foto: Illustrationsfoto / Wikimedia Commons</a:t>
             </a:r>
             <a:endParaRPr lang="en-US" sz="1000" dirty="0"/>
           </a:p>
@@ -11135,43 +10277,40 @@
           </a:p>
         </p:txBody>
       </p:sp>
-      <p:sp>
-        <p:nvSpPr>
-          <p:cNvPr id="6" name="Bildplatzhalter"/>
-          <p:cNvSpPr/>
-          <p:nvPr/>
-        </p:nvSpPr>
-        <p:spPr>
-          <a:xfrm>
-            <a:off x="6217920" y="822960"/>
-            <a:ext cx="2514600" cy="2651760"/>
-          </a:xfrm>
-          <a:prstGeom prst="roundRect">
-            <a:avLst>
-              <a:gd name="adj" fmla="val 5455"/>
-            </a:avLst>
-          </a:prstGeom>
-          <a:solidFill>
-            <a:srgbClr val="12304D"/>
-          </a:solidFill>
-          <a:ln w="12700">
-            <a:solidFill>
-              <a:srgbClr val="12304D"/>
-            </a:solidFill>
-            <a:prstDash val="solid"/>
-          </a:ln>
-        </p:spPr>
-      </p:sp>
-      <p:sp>
-        <p:nvSpPr>
-          <p:cNvPr id="7" name="Text 5"/>
-          <p:cNvSpPr txBox="1"/>
-          <p:nvPr/>
-        </p:nvSpPr>
-        <p:spPr>
-          <a:xfrm>
-            <a:off x="6217920" y="960120"/>
-            <a:ext cx="2514600" cy="822960"/>
+      <p:pic>
+        <p:nvPicPr>
+          <p:cNvPr id="6" name="Foto" descr="Mensch und humanoider Roboter stehen gemeinsam auf einer Aussichtsplattform.">    </p:cNvPr>
+          <p:cNvPicPr>
+            <a:picLocks noChangeAspect="1"/>
+          </p:cNvPicPr>
+          <p:nvPr/>
+        </p:nvPicPr>
+        <p:blipFill>
+          <a:blip r:embed="rId1"/>
+          <a:stretch>
+            <a:fillRect/>
+          </a:stretch>
+        </p:blipFill>
+        <p:spPr>
+          <a:xfrm>
+            <a:off x="6217920" y="457200"/>
+            <a:ext cx="2514600" cy="3291840"/>
+          </a:xfrm>
+          <a:prstGeom prst="rect">
+            <a:avLst/>
+          </a:prstGeom>
+        </p:spPr>
+      </p:pic>
+      <p:sp>
+        <p:nvSpPr>
+          <p:cNvPr id="7" name="Text 4"/>
+          <p:cNvSpPr txBox="1"/>
+          <p:nvPr/>
+        </p:nvSpPr>
+        <p:spPr>
+          <a:xfrm>
+            <a:off x="6217920" y="3822192"/>
+            <a:ext cx="2514600" cy="201168"/>
           </a:xfrm>
           <a:prstGeom prst="rect">
             <a:avLst/>
@@ -11183,82 +10322,7 @@
           <a:bodyPr wrap="square" lIns="0" tIns="0" rIns="0" bIns="0" rtlCol="0" anchor="ctr"/>
           <a:lstStyle/>
           <a:p>
-            <a:pPr algn="ctr" indent="0" marL="0">
-              <a:buNone/>
-            </a:pPr>
-            <a:r>
-              <a:rPr lang="en-US" sz="5400" b="1" dirty="0">
-                <a:solidFill>
-                  <a:srgbClr val="FF7A1A"/>
-                </a:solidFill>
-                <a:latin typeface="Cambria" pitchFamily="34" charset="0"/>
-                <a:ea typeface="Cambria" pitchFamily="34" charset="-122"/>
-                <a:cs typeface="Cambria" pitchFamily="34" charset="-120"/>
-              </a:rPr>
-              <a:t>30</a:t>
-            </a:r>
-            <a:endParaRPr lang="en-US" sz="5400" dirty="0"/>
-          </a:p>
-        </p:txBody>
-      </p:sp>
-      <p:sp>
-        <p:nvSpPr>
-          <p:cNvPr id="8" name="Text 6"/>
-          <p:cNvSpPr txBox="1"/>
-          <p:nvPr/>
-        </p:nvSpPr>
-        <p:spPr>
-          <a:xfrm>
-            <a:off x="6446520" y="1874520"/>
-            <a:ext cx="2057400" cy="1463040"/>
-          </a:xfrm>
-          <a:prstGeom prst="rect">
-            <a:avLst/>
-          </a:prstGeom>
-          <a:noFill/>
-          <a:ln/>
-        </p:spPr>
-        <p:txBody>
-          <a:bodyPr wrap="square" lIns="0" tIns="0" rIns="0" bIns="0" rtlCol="0" anchor="t"/>
-          <a:lstStyle/>
-          <a:p>
-            <a:pPr algn="ctr" indent="0" marL="0">
-              <a:buNone/>
-            </a:pPr>
-            <a:r>
-              <a:rPr lang="en-US" sz="1300" i="1" dirty="0">
-                <a:solidFill>
-                  <a:srgbClr val="EAF1F7"/>
-                </a:solidFill>
-              </a:rPr>
-              <a:t>Mensch und humanoider Roboter stehen gemeinsam auf einer Aussichtsplattform.</a:t>
-            </a:r>
-            <a:endParaRPr lang="en-US" sz="1300" dirty="0"/>
-          </a:p>
-        </p:txBody>
-      </p:sp>
-      <p:sp>
-        <p:nvSpPr>
-          <p:cNvPr id="9" name="Text 7"/>
-          <p:cNvSpPr txBox="1"/>
-          <p:nvPr/>
-        </p:nvSpPr>
-        <p:spPr>
-          <a:xfrm>
-            <a:off x="6217920" y="3566160"/>
-            <a:ext cx="2514600" cy="228600"/>
-          </a:xfrm>
-          <a:prstGeom prst="rect">
-            <a:avLst/>
-          </a:prstGeom>
-          <a:noFill/>
-          <a:ln/>
-        </p:spPr>
-        <p:txBody>
-          <a:bodyPr wrap="square" lIns="0" tIns="0" rIns="0" bIns="0" rtlCol="0" anchor="ctr"/>
-          <a:lstStyle/>
-          <a:p>
-            <a:pPr algn="ctr" indent="0" marL="0">
+            <a:pPr indent="0" marL="0">
               <a:buNone/>
             </a:pPr>
             <a:r>
@@ -11267,7 +10331,7 @@
                   <a:srgbClr val="5B7C99"/>
                 </a:solidFill>
               </a:rPr>
-              <a:t>Bildmotiv (Platzhalter)</a:t>
+              <a:t>Foto: Illustrationsfoto / Wikimedia Commons</a:t>
             </a:r>
             <a:endParaRPr lang="en-US" sz="1000" dirty="0"/>
           </a:p>
@@ -12321,43 +11385,40 @@
           </a:p>
         </p:txBody>
       </p:sp>
-      <p:sp>
-        <p:nvSpPr>
-          <p:cNvPr id="6" name="Bildplatzhalter"/>
-          <p:cNvSpPr/>
-          <p:nvPr/>
-        </p:nvSpPr>
-        <p:spPr>
-          <a:xfrm>
-            <a:off x="6217920" y="822960"/>
-            <a:ext cx="2514600" cy="2651760"/>
-          </a:xfrm>
-          <a:prstGeom prst="roundRect">
-            <a:avLst>
-              <a:gd name="adj" fmla="val 5455"/>
-            </a:avLst>
-          </a:prstGeom>
-          <a:solidFill>
-            <a:srgbClr val="12304D"/>
-          </a:solidFill>
-          <a:ln w="12700">
-            <a:solidFill>
-              <a:srgbClr val="12304D"/>
-            </a:solidFill>
-            <a:prstDash val="solid"/>
-          </a:ln>
-        </p:spPr>
-      </p:sp>
-      <p:sp>
-        <p:nvSpPr>
-          <p:cNvPr id="7" name="Text 5"/>
-          <p:cNvSpPr txBox="1"/>
-          <p:nvPr/>
-        </p:nvSpPr>
-        <p:spPr>
-          <a:xfrm>
-            <a:off x="6217920" y="960120"/>
-            <a:ext cx="2514600" cy="822960"/>
+      <p:pic>
+        <p:nvPicPr>
+          <p:cNvPr id="6" name="Foto" descr="Zweibeinige Roboter an der Startlinie einer roten Stadion-Laufbahn und beim Fußball.">    </p:cNvPr>
+          <p:cNvPicPr>
+            <a:picLocks noChangeAspect="1"/>
+          </p:cNvPicPr>
+          <p:nvPr/>
+        </p:nvPicPr>
+        <p:blipFill>
+          <a:blip r:embed="rId1"/>
+          <a:stretch>
+            <a:fillRect/>
+          </a:stretch>
+        </p:blipFill>
+        <p:spPr>
+          <a:xfrm>
+            <a:off x="6217920" y="457200"/>
+            <a:ext cx="2514600" cy="3291840"/>
+          </a:xfrm>
+          <a:prstGeom prst="rect">
+            <a:avLst/>
+          </a:prstGeom>
+        </p:spPr>
+      </p:pic>
+      <p:sp>
+        <p:nvSpPr>
+          <p:cNvPr id="7" name="Text 4"/>
+          <p:cNvSpPr txBox="1"/>
+          <p:nvPr/>
+        </p:nvSpPr>
+        <p:spPr>
+          <a:xfrm>
+            <a:off x="6217920" y="3822192"/>
+            <a:ext cx="2514600" cy="201168"/>
           </a:xfrm>
           <a:prstGeom prst="rect">
             <a:avLst/>
@@ -12369,82 +11430,7 @@
           <a:bodyPr wrap="square" lIns="0" tIns="0" rIns="0" bIns="0" rtlCol="0" anchor="ctr"/>
           <a:lstStyle/>
           <a:p>
-            <a:pPr algn="ctr" indent="0" marL="0">
-              <a:buNone/>
-            </a:pPr>
-            <a:r>
-              <a:rPr lang="en-US" sz="5400" b="1" dirty="0">
-                <a:solidFill>
-                  <a:srgbClr val="FF7A1A"/>
-                </a:solidFill>
-                <a:latin typeface="Cambria" pitchFamily="34" charset="0"/>
-                <a:ea typeface="Cambria" pitchFamily="34" charset="-122"/>
-                <a:cs typeface="Cambria" pitchFamily="34" charset="-120"/>
-              </a:rPr>
-              <a:t>06</a:t>
-            </a:r>
-            <a:endParaRPr lang="en-US" sz="5400" dirty="0"/>
-          </a:p>
-        </p:txBody>
-      </p:sp>
-      <p:sp>
-        <p:nvSpPr>
-          <p:cNvPr id="8" name="Text 6"/>
-          <p:cNvSpPr txBox="1"/>
-          <p:nvPr/>
-        </p:nvSpPr>
-        <p:spPr>
-          <a:xfrm>
-            <a:off x="6446520" y="1874520"/>
-            <a:ext cx="2057400" cy="1463040"/>
-          </a:xfrm>
-          <a:prstGeom prst="rect">
-            <a:avLst/>
-          </a:prstGeom>
-          <a:noFill/>
-          <a:ln/>
-        </p:spPr>
-        <p:txBody>
-          <a:bodyPr wrap="square" lIns="0" tIns="0" rIns="0" bIns="0" rtlCol="0" anchor="t"/>
-          <a:lstStyle/>
-          <a:p>
-            <a:pPr algn="ctr" indent="0" marL="0">
-              <a:buNone/>
-            </a:pPr>
-            <a:r>
-              <a:rPr lang="en-US" sz="1300" i="1" dirty="0">
-                <a:solidFill>
-                  <a:srgbClr val="EAF1F7"/>
-                </a:solidFill>
-              </a:rPr>
-              <a:t>Zweibeinige Roboter an der Startlinie einer roten Stadion-Laufbahn und beim Fußball.</a:t>
-            </a:r>
-            <a:endParaRPr lang="en-US" sz="1300" dirty="0"/>
-          </a:p>
-        </p:txBody>
-      </p:sp>
-      <p:sp>
-        <p:nvSpPr>
-          <p:cNvPr id="9" name="Text 7"/>
-          <p:cNvSpPr txBox="1"/>
-          <p:nvPr/>
-        </p:nvSpPr>
-        <p:spPr>
-          <a:xfrm>
-            <a:off x="6217920" y="3566160"/>
-            <a:ext cx="2514600" cy="228600"/>
-          </a:xfrm>
-          <a:prstGeom prst="rect">
-            <a:avLst/>
-          </a:prstGeom>
-          <a:noFill/>
-          <a:ln/>
-        </p:spPr>
-        <p:txBody>
-          <a:bodyPr wrap="square" lIns="0" tIns="0" rIns="0" bIns="0" rtlCol="0" anchor="ctr"/>
-          <a:lstStyle/>
-          <a:p>
-            <a:pPr algn="ctr" indent="0" marL="0">
+            <a:pPr indent="0" marL="0">
               <a:buNone/>
             </a:pPr>
             <a:r>
@@ -12453,7 +11439,7 @@
                   <a:srgbClr val="5B7C99"/>
                 </a:solidFill>
               </a:rPr>
-              <a:t>Bildmotiv (Platzhalter)</a:t>
+              <a:t>Foto: Illustrationsfoto / Wikimedia Commons</a:t>
             </a:r>
             <a:endParaRPr lang="en-US" sz="1000" dirty="0"/>
           </a:p>

</xml_diff>

<commit_message>
Add video links to slides 20-30
Co-Authored-By: Claude Sonnet 5.5 <noreply@anthropic.com>
Claude-Session: https://claude.ai/code/session_01QoBEPxbicZNbtosTbAi2im
</commit_message>
<xml_diff>
--- a/Humanoide_Roboter_gross.pptx
+++ b/Humanoide_Roboter_gross.pptx
@@ -137,7 +137,7 @@
   <p:extLst>
     <p:ext uri="{521415D9-36F7-43E2-AB2F-B90AF26B5E84}">
       <p14:sectionLst xmlns:p14="http://schemas.microsoft.com/office/powerpoint/2010/main">
-        <p14:section name="Teil 1: Geschichte der humanoiden Roboter" id="{7b2e4899-ef13-2ea7-3c4a-c8af2143a209}">
+        <p14:section name="Teil 1: Geschichte der humanoiden Roboter" id="{c7b420f0-4fa7-ad42-e6ef-f0e64016a777}">
           <p14:sldIdLst>
             <p14:sldId id="257"/>
             <p14:sldId id="258"/>
@@ -146,7 +146,7 @@
             <p14:sldId id="261"/>
           </p14:sldIdLst>
         </p14:section>
-        <p14:section name="Teil 2: Sport, Athletik und Wettkämpfe" id="{7ad5eee4-c09b-2c78-f9e7-385954bf3269}">
+        <p14:section name="Teil 2: Sport, Athletik und Wettkämpfe" id="{10df1e91-dc04-0923-759c-c33b1e54051b}">
           <p14:sldIdLst>
             <p14:sldId id="262"/>
             <p14:sldId id="263"/>
@@ -156,7 +156,7 @@
             <p14:sldId id="267"/>
           </p14:sldIdLst>
         </p14:section>
-        <p14:section name="Teil 3: Industrie &amp; Fabriken" id="{4e3b65bb-26b3-e960-2c5f-9340b27e64d7}">
+        <p14:section name="Teil 3: Industrie &amp; Fabriken" id="{bae874c0-5d35-e1f8-530e-b6a6ad7ee248}">
           <p14:sldIdLst>
             <p14:sldId id="268"/>
             <p14:sldId id="269"/>
@@ -166,7 +166,7 @@
             <p14:sldId id="273"/>
           </p14:sldIdLst>
         </p14:section>
-        <p14:section name="Teil 4: Künstliche Intelligenz &amp; Schlüsseltechnologien" id="{00005871-94af-a3bf-8657-4922341c34cd}">
+        <p14:section name="Teil 4: Künstliche Intelligenz &amp; Schlüsseltechnologien" id="{fcb14f49-97ad-331b-5508-371e79b4385a}">
           <p14:sldIdLst>
             <p14:sldId id="274"/>
             <p14:sldId id="275"/>
@@ -176,7 +176,7 @@
             <p14:sldId id="279"/>
           </p14:sldIdLst>
         </p14:section>
-        <p14:section name="Teil 5: Haushaltsroboter &amp; Zukunftsprognosen" id="{7e337701-efab-4a25-d548-0f2628691a7b}">
+        <p14:section name="Teil 5: Haushaltsroboter &amp; Zukunftsprognosen" id="{217c43f4-ee60-a027-f2c0-d6e9f56f6f34}">
           <p14:sldIdLst>
             <p14:sldId id="280"/>
             <p14:sldId id="281"/>
@@ -1735,7 +1735,7 @@
           <a:p>
             <a:r>
               <a:rPr lang="en-US" dirty="0"/>
-              <a:t>Bildmotiv: 3D-Physiksimulation am Monitor zeigt Hunderte parallele virtuelle Trainingsroboter.</a:t>
+              <a:t>Bildmotiv: 3D-Physiksimulation am Monitor zeigt Hunderte parallele virtuelle Trainingsroboter. | Video: https://www.youtube.com/watch?v=93Is26tQ07o (Simulate Robot Fleets in Digital Twins (NVIDIA Omniverse)). Im Original-Dokument angegeben als: Simulate Robot Fleets in Digital Twins (NVIDIA Omniverse)</a:t>
             </a:r>
             <a:endParaRPr lang="en-US" dirty="0"/>
           </a:p>
@@ -1823,7 +1823,7 @@
           <a:p>
             <a:r>
               <a:rPr lang="en-US" dirty="0"/>
-              <a:t>Bildmotiv: Sanfte Berührung zwischen einem menschlichen Arm und einem weich nachgebenden Roboterarm. | Foto: Illustrationsfoto, Wikimedia Commons (Lizenz vor Veröffentlichung prüfen).</a:t>
+              <a:t>Bildmotiv: Sanfte Berührung zwischen einem menschlichen Arm und einem weich nachgebenden Roboterarm. | Video: https://www.youtube.com/watch?v=rruX0RrnRcw (Unitree Humanoid Withstands Kicks and Shoves). Im Original-Dokument angegeben als: Unitree Humanoid Withstands Kicks and Shoves</a:t>
             </a:r>
             <a:endParaRPr lang="en-US" dirty="0"/>
           </a:p>
@@ -1911,7 +1911,7 @@
           <a:p>
             <a:r>
               <a:rPr lang="en-US" dirty="0"/>
-              <a:t>Bildmotiv: Querschnitt eines Elektromotors und ein modulares Akkupaket. | Foto: Illustrationsfoto, Wikimedia Commons (Lizenz vor Veröffentlichung prüfen).</a:t>
+              <a:t>Bildmotiv: Querschnitt eines Elektromotors und ein modulares Akkupaket. | Video: https://www.youtube.com/watch?v=ZQ4Sqihq_kQ (Humanoid Robot Can Swap Its Own Battery Pack (CNET)). Im Original-Dokument angegeben als: Humanoid Robot Can Swap Its Own Battery Pack (CNET)</a:t>
             </a:r>
             <a:endParaRPr lang="en-US" dirty="0"/>
           </a:p>
@@ -1999,7 +1999,7 @@
           <a:p>
             <a:r>
               <a:rPr lang="en-US" dirty="0"/>
-              <a:t>Bildmotiv: 3D-Tiefenkarte eines Wohnraums mit erkannten Objekten und Hindernissen. | Foto: Illustrationsfoto, Wikimedia Commons (Lizenz vor Veröffentlichung prüfen).</a:t>
+              <a:t>Bildmotiv: 3D-Tiefenkarte eines Wohnraums mit erkannten Objekten und Hindernissen. | Video: https://www.youtube.com/watch?v=QSnv7bEbrac (How Robots Build Maps (LiDAR + SLAM Explained)). Im Original-Dokument angegeben als: How Robots Build Maps (LiDAR + SLAM Explained)</a:t>
             </a:r>
             <a:endParaRPr lang="en-US" dirty="0"/>
           </a:p>
@@ -2175,7 +2175,7 @@
           <a:p>
             <a:r>
               <a:rPr lang="en-US" dirty="0"/>
-              <a:t>Bildmotiv: Roboterhände falten ein weißes Handtuch, daneben der kompakte Unitree G1.</a:t>
+              <a:t>Bildmotiv: Roboterhände falten ein weißes Handtuch, daneben der kompakte Unitree G1. | Video: https://www.youtube.com/watch?v=Wn2AzxnmxQE (Unitree G1 Home Task Demo). Im Original-Dokument angegeben als: Unitree G1 Home Task Demo</a:t>
             </a:r>
             <a:endParaRPr lang="en-US" dirty="0"/>
           </a:p>
@@ -2263,7 +2263,7 @@
           <a:p>
             <a:r>
               <a:rPr lang="en-US" dirty="0"/>
-              <a:t>Bildmotiv: Roboter stützt sanft eine ältere Person beim Gehen im Flur eines Seniorenheims. | Foto: Illustrationsfoto, Wikimedia Commons (Lizenz vor Veröffentlichung prüfen).</a:t>
+              <a:t>Bildmotiv: Roboter stützt sanft eine ältere Person beim Gehen im Flur eines Seniorenheims. | Video: https://www.youtube.com/watch?v=OO-yrowDiAo (Meet Abi, the humanoid robot in care homes (Reuters)). Im Original-Dokument angegeben als: Meet Abi, the humanoid robot in care homes (Reuters)</a:t>
             </a:r>
             <a:endParaRPr lang="en-US" dirty="0"/>
           </a:p>
@@ -2351,7 +2351,7 @@
           <a:p>
             <a:r>
               <a:rPr lang="en-US" dirty="0"/>
-              <a:t>Bildmotiv: Wachstumsdiagramm und eine Tablet-App für die Roboter-Miete.</a:t>
+              <a:t>Bildmotiv: Wachstumsdiagramm und eine Tablet-App für die Roboter-Miete. | Video: https://www.youtube.com/watch?v=uw4CrEWjO2Y (Rentable humanoid robots (CBS Texas)). Im Original-Dokument angegeben als: Rentable humanoid robots (CBS Texas)</a:t>
             </a:r>
             <a:endParaRPr lang="en-US" dirty="0"/>
           </a:p>
@@ -2439,7 +2439,7 @@
           <a:p>
             <a:r>
               <a:rPr lang="en-US" dirty="0"/>
-              <a:t>Bildmotiv: Ein digitales Schloss-Symbol vor einem Wohnzimmer-Hintergrund für Datenschutz. | Foto: Illustrationsfoto, Wikimedia Commons (Lizenz vor Veröffentlichung prüfen).</a:t>
+              <a:t>Bildmotiv: Ein digitales Schloss-Symbol vor einem Wohnzimmer-Hintergrund für Datenschutz. | Video: https://www.youtube.com/watch?v=f3c4mQty_so (I Tried the First Humanoid Home Robot (WSJ)). Im Original-Dokument angegeben als: I Tried the First Humanoid Home Robot (WSJ)</a:t>
             </a:r>
             <a:endParaRPr lang="en-US" dirty="0"/>
           </a:p>
@@ -2615,7 +2615,7 @@
           <a:p>
             <a:r>
               <a:rPr lang="en-US" dirty="0"/>
-              <a:t>Bildmotiv: Ingenieure prüfen neue Materialien und Batterien im Entwicklungszentrum. | Foto: Illustrationsfoto, Wikimedia Commons (Lizenz vor Veröffentlichung prüfen).</a:t>
+              <a:t>Bildmotiv: Ingenieure prüfen neue Materialien und Batterien im Entwicklungszentrum. | Video: https://www.youtube.com/watch?v=KRyqxhB38JY (Battery Life Doubled from 4 to 8 Hours (The Neuron)). Im Original-Dokument angegeben als: Battery Life Doubled from 4 to 8 Hours (The Neuron)</a:t>
             </a:r>
             <a:endParaRPr lang="en-US" dirty="0"/>
           </a:p>
@@ -2703,7 +2703,7 @@
           <a:p>
             <a:r>
               <a:rPr lang="en-US" dirty="0"/>
-              <a:t>Bildmotiv: Mensch und humanoider Roboter stehen gemeinsam auf einer Aussichtsplattform. | Foto: Illustrationsfoto, Wikimedia Commons (Lizenz vor Veröffentlichung prüfen).</a:t>
+              <a:t>Bildmotiv: Mensch und humanoider Roboter stehen gemeinsam auf einer Aussichtsplattform. | Video: https://www.youtube.com/watch?v=U1JJN1tEvJw (Will humans and robots work together soon? (CGTN)). Im Original-Dokument angegeben als: Will humans and robots work together soon? (CGTN)</a:t>
             </a:r>
             <a:endParaRPr lang="en-US" dirty="0"/>
           </a:p>
@@ -7354,28 +7354,83 @@
           </a:p>
         </p:txBody>
       </p:sp>
-      <p:sp>
-        <p:nvSpPr>
-          <p:cNvPr id="6" name="Bildplatzhalter"/>
+      <p:pic>
+        <p:nvPicPr>
+          <p:cNvPr id="6" name="Video-Vorschau" descr="3D-Physiksimulation am Monitor zeigt Hunderte parallele virtuelle Trainingsroboter.">
+            <a:hlinkClick r:id="rId2" tooltip="Video auf YouTube öffnen"/>
+          </p:cNvPr>
+          <p:cNvPicPr>
+            <a:picLocks noChangeAspect="1"/>
+          </p:cNvPicPr>
+          <p:nvPr/>
+        </p:nvPicPr>
+        <p:blipFill>
+          <a:blip r:embed="rId1"/>
+          <a:stretch>
+            <a:fillRect/>
+          </a:stretch>
+        </p:blipFill>
+        <p:spPr>
+          <a:xfrm>
+            <a:off x="6217920" y="822960"/>
+            <a:ext cx="2514600" cy="1414463"/>
+          </a:xfrm>
+          <a:prstGeom prst="rect">
+            <a:avLst/>
+          </a:prstGeom>
+        </p:spPr>
+      </p:pic>
+      <p:sp>
+        <p:nvSpPr>
+          <p:cNvPr id="7" name="Play-Kreis">
+            <a:hlinkClick r:id="rId3" tooltip=""/>
+          </p:cNvPr>
           <p:cNvSpPr/>
           <p:nvPr/>
         </p:nvSpPr>
         <p:spPr>
           <a:xfrm>
-            <a:off x="6217920" y="822960"/>
-            <a:ext cx="2514600" cy="2651760"/>
-          </a:xfrm>
-          <a:prstGeom prst="roundRect">
-            <a:avLst>
-              <a:gd name="adj" fmla="val 5455"/>
-            </a:avLst>
+            <a:off x="7155180" y="1210151"/>
+            <a:ext cx="640080" cy="640080"/>
+          </a:xfrm>
+          <a:prstGeom prst="ellipse">
+            <a:avLst/>
           </a:prstGeom>
           <a:solidFill>
-            <a:srgbClr val="12304D"/>
+            <a:srgbClr val="0B1F33">
+              <a:alpha val="75000"/>
+            </a:srgbClr>
+          </a:solidFill>
+          <a:ln w="25400">
+            <a:solidFill>
+              <a:srgbClr val="FFFFFF"/>
+            </a:solidFill>
+            <a:prstDash val="solid"/>
+          </a:ln>
+        </p:spPr>
+      </p:sp>
+      <p:sp>
+        <p:nvSpPr>
+          <p:cNvPr id="8" name="Play-Dreieck">
+            <a:hlinkClick r:id="rId4" tooltip=""/>
+          </p:cNvPr>
+          <p:cNvSpPr/>
+          <p:nvPr/>
+        </p:nvSpPr>
+        <p:spPr>
+          <a:xfrm rot="5400000">
+            <a:off x="7383780" y="1383887"/>
+            <a:ext cx="256032" cy="292608"/>
+          </a:xfrm>
+          <a:prstGeom prst="triangle">
+            <a:avLst/>
+          </a:prstGeom>
+          <a:solidFill>
+            <a:srgbClr val="FFFFFF"/>
           </a:solidFill>
           <a:ln w="12700">
             <a:solidFill>
-              <a:srgbClr val="12304D"/>
+              <a:srgbClr val="FFFFFF"/>
             </a:solidFill>
             <a:prstDash val="solid"/>
           </a:ln>
@@ -7383,53 +7438,14 @@
       </p:sp>
       <p:sp>
         <p:nvSpPr>
-          <p:cNvPr id="7" name="Text 5"/>
-          <p:cNvSpPr txBox="1"/>
-          <p:nvPr/>
-        </p:nvSpPr>
-        <p:spPr>
-          <a:xfrm>
-            <a:off x="6217920" y="960120"/>
-            <a:ext cx="2514600" cy="822960"/>
-          </a:xfrm>
-          <a:prstGeom prst="rect">
-            <a:avLst/>
-          </a:prstGeom>
-          <a:noFill/>
-          <a:ln/>
-        </p:spPr>
-        <p:txBody>
-          <a:bodyPr wrap="square" lIns="0" tIns="0" rIns="0" bIns="0" rtlCol="0" anchor="ctr"/>
-          <a:lstStyle/>
-          <a:p>
-            <a:pPr algn="ctr" indent="0" marL="0">
-              <a:buNone/>
-            </a:pPr>
-            <a:r>
-              <a:rPr lang="en-US" sz="5400" b="1" dirty="0">
-                <a:solidFill>
-                  <a:srgbClr val="FF7A1A"/>
-                </a:solidFill>
-                <a:latin typeface="Cambria" pitchFamily="34" charset="0"/>
-                <a:ea typeface="Cambria" pitchFamily="34" charset="-122"/>
-                <a:cs typeface="Cambria" pitchFamily="34" charset="-120"/>
-              </a:rPr>
-              <a:t>20</a:t>
-            </a:r>
-            <a:endParaRPr lang="en-US" sz="5400" dirty="0"/>
-          </a:p>
-        </p:txBody>
-      </p:sp>
-      <p:sp>
-        <p:nvSpPr>
-          <p:cNvPr id="8" name="Text 6"/>
-          <p:cNvSpPr txBox="1"/>
-          <p:nvPr/>
-        </p:nvSpPr>
-        <p:spPr>
-          <a:xfrm>
-            <a:off x="6446520" y="1874520"/>
-            <a:ext cx="2057400" cy="1463040"/>
+          <p:cNvPr id="9" name="Video-Link"/>
+          <p:cNvSpPr txBox="1"/>
+          <p:nvPr/>
+        </p:nvSpPr>
+        <p:spPr>
+          <a:xfrm>
+            <a:off x="6217920" y="3566160"/>
+            <a:ext cx="2514600" cy="502920"/>
           </a:xfrm>
           <a:prstGeom prst="rect">
             <a:avLst/>
@@ -7441,54 +7457,39 @@
           <a:bodyPr wrap="square" lIns="0" tIns="0" rIns="0" bIns="0" rtlCol="0" anchor="t"/>
           <a:lstStyle/>
           <a:p>
-            <a:pPr algn="ctr" indent="0" marL="0">
-              <a:buNone/>
-            </a:pPr>
-            <a:r>
-              <a:rPr lang="en-US" sz="1300" i="1" dirty="0">
-                <a:solidFill>
-                  <a:srgbClr val="EAF1F7"/>
-                </a:solidFill>
-              </a:rPr>
-              <a:t>3D-Physiksimulation am Monitor zeigt Hunderte parallele virtuelle Trainingsroboter.</a:t>
+            <a:pPr indent="0" marL="0">
+              <a:buNone/>
+            </a:pPr>
+            <a:r>
+              <a:rPr lang="en-US" sz="1300" b="1" u="sng" dirty="0">
+                <a:solidFill>
+                  <a:schemeClr val="accent1"/>
+                </a:solidFill>
+                <a:hlinkClick r:id="rId5" invalidUrl="" action="" tgtFrame="" tooltip="https://www.youtube.com/watch?v=93Is26tQ07o" history="1" highlightClick="0" endSnd="0">
+                  <a:extLst>
+                    <a:ext uri="{A12FA001-AC4F-418D-AE19-62706E023703}">
+                      <ahyp:hlinkClr xmlns:ahyp="http://schemas.microsoft.com/office/drawing/2018/hyperlinkcolor" val="tx"/>
+                    </a:ext>
+                  </a:extLst>
+                </a:hlinkClick>
+              </a:rPr>
+              <a:t>▶ Video ansehen</a:t>
             </a:r>
             <a:endParaRPr lang="en-US" sz="1300" dirty="0"/>
           </a:p>
-        </p:txBody>
-      </p:sp>
-      <p:sp>
-        <p:nvSpPr>
-          <p:cNvPr id="9" name="Text 7"/>
-          <p:cNvSpPr txBox="1"/>
-          <p:nvPr/>
-        </p:nvSpPr>
-        <p:spPr>
-          <a:xfrm>
-            <a:off x="6217920" y="3566160"/>
-            <a:ext cx="2514600" cy="228600"/>
-          </a:xfrm>
-          <a:prstGeom prst="rect">
-            <a:avLst/>
-          </a:prstGeom>
-          <a:noFill/>
-          <a:ln/>
-        </p:spPr>
-        <p:txBody>
-          <a:bodyPr wrap="square" lIns="0" tIns="0" rIns="0" bIns="0" rtlCol="0" anchor="ctr"/>
-          <a:lstStyle/>
-          <a:p>
-            <a:pPr algn="ctr" indent="0" marL="0">
-              <a:buNone/>
-            </a:pPr>
-            <a:r>
-              <a:rPr lang="en-US" sz="1000" dirty="0">
-                <a:solidFill>
-                  <a:srgbClr val="5B7C99"/>
-                </a:solidFill>
-              </a:rPr>
-              <a:t>Bildmotiv (Platzhalter)</a:t>
-            </a:r>
-            <a:endParaRPr lang="en-US" sz="1000" dirty="0"/>
+          <a:p>
+            <a:pPr indent="0" marL="0">
+              <a:buNone/>
+            </a:pPr>
+            <a:r>
+              <a:rPr lang="en-US" sz="1100" dirty="0">
+                <a:solidFill>
+                  <a:schemeClr val="accent3"/>
+                </a:solidFill>
+              </a:rPr>
+              <a:t>Simulate Robot Fleets in Digital Twins (NVIDIA Omniverse)</a:t>
+            </a:r>
+            <a:endParaRPr lang="en-US" sz="1300" dirty="0"/>
           </a:p>
         </p:txBody>
       </p:sp>
@@ -7668,7 +7669,9 @@
       </p:sp>
       <p:pic>
         <p:nvPicPr>
-          <p:cNvPr id="6" name="Foto" descr="Sanfte Berührung zwischen einem menschlichen Arm und einem weich nachgebenden Roboterarm.">    </p:cNvPr>
+          <p:cNvPr id="6" name="Video-Vorschau" descr="Sanfte Berührung zwischen einem menschlichen Arm und einem weich nachgebenden Roboterarm.">
+            <a:hlinkClick r:id="rId2" tooltip="Video auf YouTube öffnen"/>
+          </p:cNvPr>
           <p:cNvPicPr>
             <a:picLocks noChangeAspect="1"/>
           </p:cNvPicPr>
@@ -7682,8 +7685,8 @@
         </p:blipFill>
         <p:spPr>
           <a:xfrm>
-            <a:off x="6217920" y="457200"/>
-            <a:ext cx="2514600" cy="3291840"/>
+            <a:off x="6217920" y="822960"/>
+            <a:ext cx="2514600" cy="1414463"/>
           </a:xfrm>
           <a:prstGeom prst="rect">
             <a:avLst/>
@@ -7692,37 +7695,114 @@
       </p:pic>
       <p:sp>
         <p:nvSpPr>
-          <p:cNvPr id="7" name="Text 4"/>
-          <p:cNvSpPr txBox="1"/>
-          <p:nvPr/>
-        </p:nvSpPr>
-        <p:spPr>
-          <a:xfrm>
-            <a:off x="6217920" y="3822192"/>
-            <a:ext cx="2514600" cy="201168"/>
-          </a:xfrm>
-          <a:prstGeom prst="rect">
-            <a:avLst/>
-          </a:prstGeom>
-          <a:noFill/>
-          <a:ln/>
-        </p:spPr>
-        <p:txBody>
-          <a:bodyPr wrap="square" lIns="0" tIns="0" rIns="0" bIns="0" rtlCol="0" anchor="ctr"/>
-          <a:lstStyle/>
-          <a:p>
-            <a:pPr indent="0" marL="0">
-              <a:buNone/>
-            </a:pPr>
-            <a:r>
-              <a:rPr lang="en-US" sz="1000" dirty="0">
-                <a:solidFill>
-                  <a:srgbClr val="5B7C99"/>
-                </a:solidFill>
-              </a:rPr>
-              <a:t>Foto: Illustrationsfoto / Wikimedia Commons</a:t>
-            </a:r>
-            <a:endParaRPr lang="en-US" sz="1000" dirty="0"/>
+          <p:cNvPr id="7" name="Play-Kreis">
+            <a:hlinkClick r:id="rId3" tooltip=""/>
+          </p:cNvPr>
+          <p:cNvSpPr/>
+          <p:nvPr/>
+        </p:nvSpPr>
+        <p:spPr>
+          <a:xfrm>
+            <a:off x="7155180" y="1210151"/>
+            <a:ext cx="640080" cy="640080"/>
+          </a:xfrm>
+          <a:prstGeom prst="ellipse">
+            <a:avLst/>
+          </a:prstGeom>
+          <a:solidFill>
+            <a:srgbClr val="0B1F33">
+              <a:alpha val="75000"/>
+            </a:srgbClr>
+          </a:solidFill>
+          <a:ln w="25400">
+            <a:solidFill>
+              <a:srgbClr val="FFFFFF"/>
+            </a:solidFill>
+            <a:prstDash val="solid"/>
+          </a:ln>
+        </p:spPr>
+      </p:sp>
+      <p:sp>
+        <p:nvSpPr>
+          <p:cNvPr id="8" name="Play-Dreieck">
+            <a:hlinkClick r:id="rId4" tooltip=""/>
+          </p:cNvPr>
+          <p:cNvSpPr/>
+          <p:nvPr/>
+        </p:nvSpPr>
+        <p:spPr>
+          <a:xfrm rot="5400000">
+            <a:off x="7383780" y="1383887"/>
+            <a:ext cx="256032" cy="292608"/>
+          </a:xfrm>
+          <a:prstGeom prst="triangle">
+            <a:avLst/>
+          </a:prstGeom>
+          <a:solidFill>
+            <a:srgbClr val="FFFFFF"/>
+          </a:solidFill>
+          <a:ln w="12700">
+            <a:solidFill>
+              <a:srgbClr val="FFFFFF"/>
+            </a:solidFill>
+            <a:prstDash val="solid"/>
+          </a:ln>
+        </p:spPr>
+      </p:sp>
+      <p:sp>
+        <p:nvSpPr>
+          <p:cNvPr id="9" name="Video-Link"/>
+          <p:cNvSpPr txBox="1"/>
+          <p:nvPr/>
+        </p:nvSpPr>
+        <p:spPr>
+          <a:xfrm>
+            <a:off x="6217920" y="4069080"/>
+            <a:ext cx="2514600" cy="502920"/>
+          </a:xfrm>
+          <a:prstGeom prst="rect">
+            <a:avLst/>
+          </a:prstGeom>
+          <a:noFill/>
+          <a:ln/>
+        </p:spPr>
+        <p:txBody>
+          <a:bodyPr wrap="square" lIns="0" tIns="0" rIns="0" bIns="0" rtlCol="0" anchor="t"/>
+          <a:lstStyle/>
+          <a:p>
+            <a:pPr indent="0" marL="0">
+              <a:buNone/>
+            </a:pPr>
+            <a:r>
+              <a:rPr lang="en-US" sz="1300" b="1" u="sng" dirty="0">
+                <a:solidFill>
+                  <a:schemeClr val="accent1"/>
+                </a:solidFill>
+                <a:hlinkClick r:id="rId5" invalidUrl="" action="" tgtFrame="" tooltip="https://www.youtube.com/watch?v=rruX0RrnRcw" history="1" highlightClick="0" endSnd="0">
+                  <a:extLst>
+                    <a:ext uri="{A12FA001-AC4F-418D-AE19-62706E023703}">
+                      <ahyp:hlinkClr xmlns:ahyp="http://schemas.microsoft.com/office/drawing/2018/hyperlinkcolor" val="tx"/>
+                    </a:ext>
+                  </a:extLst>
+                </a:hlinkClick>
+              </a:rPr>
+              <a:t>▶ Video ansehen</a:t>
+            </a:r>
+            <a:endParaRPr lang="en-US" sz="1300" dirty="0"/>
+          </a:p>
+          <a:p>
+            <a:pPr indent="0" marL="0">
+              <a:buNone/>
+            </a:pPr>
+            <a:r>
+              <a:rPr lang="en-US" sz="1100" dirty="0">
+                <a:solidFill>
+                  <a:schemeClr val="accent3"/>
+                </a:solidFill>
+              </a:rPr>
+              <a:t>Unitree Humanoid Withstands Kicks and Shoves</a:t>
+            </a:r>
+            <a:endParaRPr lang="en-US" sz="1300" dirty="0"/>
           </a:p>
         </p:txBody>
       </p:sp>
@@ -7902,7 +7982,9 @@
       </p:sp>
       <p:pic>
         <p:nvPicPr>
-          <p:cNvPr id="6" name="Foto" descr="Querschnitt eines Elektromotors und ein modulares Akkupaket.">    </p:cNvPr>
+          <p:cNvPr id="6" name="Video-Vorschau" descr="Querschnitt eines Elektromotors und ein modulares Akkupaket.">
+            <a:hlinkClick r:id="rId2" tooltip="Video auf YouTube öffnen"/>
+          </p:cNvPr>
           <p:cNvPicPr>
             <a:picLocks noChangeAspect="1"/>
           </p:cNvPicPr>
@@ -7916,8 +7998,8 @@
         </p:blipFill>
         <p:spPr>
           <a:xfrm>
-            <a:off x="6217920" y="457200"/>
-            <a:ext cx="2514600" cy="3291840"/>
+            <a:off x="6217920" y="822960"/>
+            <a:ext cx="2514600" cy="1414463"/>
           </a:xfrm>
           <a:prstGeom prst="rect">
             <a:avLst/>
@@ -7926,37 +8008,114 @@
       </p:pic>
       <p:sp>
         <p:nvSpPr>
-          <p:cNvPr id="7" name="Text 4"/>
-          <p:cNvSpPr txBox="1"/>
-          <p:nvPr/>
-        </p:nvSpPr>
-        <p:spPr>
-          <a:xfrm>
-            <a:off x="6217920" y="3822192"/>
-            <a:ext cx="2514600" cy="201168"/>
-          </a:xfrm>
-          <a:prstGeom prst="rect">
-            <a:avLst/>
-          </a:prstGeom>
-          <a:noFill/>
-          <a:ln/>
-        </p:spPr>
-        <p:txBody>
-          <a:bodyPr wrap="square" lIns="0" tIns="0" rIns="0" bIns="0" rtlCol="0" anchor="ctr"/>
-          <a:lstStyle/>
-          <a:p>
-            <a:pPr indent="0" marL="0">
-              <a:buNone/>
-            </a:pPr>
-            <a:r>
-              <a:rPr lang="en-US" sz="1000" dirty="0">
-                <a:solidFill>
-                  <a:srgbClr val="5B7C99"/>
-                </a:solidFill>
-              </a:rPr>
-              <a:t>Foto: Illustrationsfoto / Wikimedia Commons</a:t>
-            </a:r>
-            <a:endParaRPr lang="en-US" sz="1000" dirty="0"/>
+          <p:cNvPr id="7" name="Play-Kreis">
+            <a:hlinkClick r:id="rId3" tooltip=""/>
+          </p:cNvPr>
+          <p:cNvSpPr/>
+          <p:nvPr/>
+        </p:nvSpPr>
+        <p:spPr>
+          <a:xfrm>
+            <a:off x="7155180" y="1210151"/>
+            <a:ext cx="640080" cy="640080"/>
+          </a:xfrm>
+          <a:prstGeom prst="ellipse">
+            <a:avLst/>
+          </a:prstGeom>
+          <a:solidFill>
+            <a:srgbClr val="0B1F33">
+              <a:alpha val="75000"/>
+            </a:srgbClr>
+          </a:solidFill>
+          <a:ln w="25400">
+            <a:solidFill>
+              <a:srgbClr val="FFFFFF"/>
+            </a:solidFill>
+            <a:prstDash val="solid"/>
+          </a:ln>
+        </p:spPr>
+      </p:sp>
+      <p:sp>
+        <p:nvSpPr>
+          <p:cNvPr id="8" name="Play-Dreieck">
+            <a:hlinkClick r:id="rId4" tooltip=""/>
+          </p:cNvPr>
+          <p:cNvSpPr/>
+          <p:nvPr/>
+        </p:nvSpPr>
+        <p:spPr>
+          <a:xfrm rot="5400000">
+            <a:off x="7383780" y="1383887"/>
+            <a:ext cx="256032" cy="292608"/>
+          </a:xfrm>
+          <a:prstGeom prst="triangle">
+            <a:avLst/>
+          </a:prstGeom>
+          <a:solidFill>
+            <a:srgbClr val="FFFFFF"/>
+          </a:solidFill>
+          <a:ln w="12700">
+            <a:solidFill>
+              <a:srgbClr val="FFFFFF"/>
+            </a:solidFill>
+            <a:prstDash val="solid"/>
+          </a:ln>
+        </p:spPr>
+      </p:sp>
+      <p:sp>
+        <p:nvSpPr>
+          <p:cNvPr id="9" name="Video-Link"/>
+          <p:cNvSpPr txBox="1"/>
+          <p:nvPr/>
+        </p:nvSpPr>
+        <p:spPr>
+          <a:xfrm>
+            <a:off x="6217920" y="4069080"/>
+            <a:ext cx="2514600" cy="502920"/>
+          </a:xfrm>
+          <a:prstGeom prst="rect">
+            <a:avLst/>
+          </a:prstGeom>
+          <a:noFill/>
+          <a:ln/>
+        </p:spPr>
+        <p:txBody>
+          <a:bodyPr wrap="square" lIns="0" tIns="0" rIns="0" bIns="0" rtlCol="0" anchor="t"/>
+          <a:lstStyle/>
+          <a:p>
+            <a:pPr indent="0" marL="0">
+              <a:buNone/>
+            </a:pPr>
+            <a:r>
+              <a:rPr lang="en-US" sz="1300" b="1" u="sng" dirty="0">
+                <a:solidFill>
+                  <a:schemeClr val="accent1"/>
+                </a:solidFill>
+                <a:hlinkClick r:id="rId5" invalidUrl="" action="" tgtFrame="" tooltip="https://www.youtube.com/watch?v=ZQ4Sqihq_kQ" history="1" highlightClick="0" endSnd="0">
+                  <a:extLst>
+                    <a:ext uri="{A12FA001-AC4F-418D-AE19-62706E023703}">
+                      <ahyp:hlinkClr xmlns:ahyp="http://schemas.microsoft.com/office/drawing/2018/hyperlinkcolor" val="tx"/>
+                    </a:ext>
+                  </a:extLst>
+                </a:hlinkClick>
+              </a:rPr>
+              <a:t>▶ Video ansehen</a:t>
+            </a:r>
+            <a:endParaRPr lang="en-US" sz="1300" dirty="0"/>
+          </a:p>
+          <a:p>
+            <a:pPr indent="0" marL="0">
+              <a:buNone/>
+            </a:pPr>
+            <a:r>
+              <a:rPr lang="en-US" sz="1100" dirty="0">
+                <a:solidFill>
+                  <a:schemeClr val="accent3"/>
+                </a:solidFill>
+              </a:rPr>
+              <a:t>Humanoid Robot Can Swap Its Own Battery Pack (CNET)</a:t>
+            </a:r>
+            <a:endParaRPr lang="en-US" sz="1300" dirty="0"/>
           </a:p>
         </p:txBody>
       </p:sp>
@@ -8136,7 +8295,9 @@
       </p:sp>
       <p:pic>
         <p:nvPicPr>
-          <p:cNvPr id="6" name="Foto" descr="3D-Tiefenkarte eines Wohnraums mit erkannten Objekten und Hindernissen.">    </p:cNvPr>
+          <p:cNvPr id="6" name="Video-Vorschau" descr="3D-Tiefenkarte eines Wohnraums mit erkannten Objekten und Hindernissen.">
+            <a:hlinkClick r:id="rId2" tooltip="Video auf YouTube öffnen"/>
+          </p:cNvPr>
           <p:cNvPicPr>
             <a:picLocks noChangeAspect="1"/>
           </p:cNvPicPr>
@@ -8150,8 +8311,8 @@
         </p:blipFill>
         <p:spPr>
           <a:xfrm>
-            <a:off x="6217920" y="457200"/>
-            <a:ext cx="2514600" cy="3291840"/>
+            <a:off x="6217920" y="822960"/>
+            <a:ext cx="2514600" cy="1414463"/>
           </a:xfrm>
           <a:prstGeom prst="rect">
             <a:avLst/>
@@ -8160,37 +8321,114 @@
       </p:pic>
       <p:sp>
         <p:nvSpPr>
-          <p:cNvPr id="7" name="Text 4"/>
-          <p:cNvSpPr txBox="1"/>
-          <p:nvPr/>
-        </p:nvSpPr>
-        <p:spPr>
-          <a:xfrm>
-            <a:off x="6217920" y="3822192"/>
-            <a:ext cx="2514600" cy="201168"/>
-          </a:xfrm>
-          <a:prstGeom prst="rect">
-            <a:avLst/>
-          </a:prstGeom>
-          <a:noFill/>
-          <a:ln/>
-        </p:spPr>
-        <p:txBody>
-          <a:bodyPr wrap="square" lIns="0" tIns="0" rIns="0" bIns="0" rtlCol="0" anchor="ctr"/>
-          <a:lstStyle/>
-          <a:p>
-            <a:pPr indent="0" marL="0">
-              <a:buNone/>
-            </a:pPr>
-            <a:r>
-              <a:rPr lang="en-US" sz="1000" dirty="0">
-                <a:solidFill>
-                  <a:srgbClr val="5B7C99"/>
-                </a:solidFill>
-              </a:rPr>
-              <a:t>Foto: Illustrationsfoto / Wikimedia Commons</a:t>
-            </a:r>
-            <a:endParaRPr lang="en-US" sz="1000" dirty="0"/>
+          <p:cNvPr id="7" name="Play-Kreis">
+            <a:hlinkClick r:id="rId3" tooltip=""/>
+          </p:cNvPr>
+          <p:cNvSpPr/>
+          <p:nvPr/>
+        </p:nvSpPr>
+        <p:spPr>
+          <a:xfrm>
+            <a:off x="7155180" y="1210151"/>
+            <a:ext cx="640080" cy="640080"/>
+          </a:xfrm>
+          <a:prstGeom prst="ellipse">
+            <a:avLst/>
+          </a:prstGeom>
+          <a:solidFill>
+            <a:srgbClr val="0B1F33">
+              <a:alpha val="75000"/>
+            </a:srgbClr>
+          </a:solidFill>
+          <a:ln w="25400">
+            <a:solidFill>
+              <a:srgbClr val="FFFFFF"/>
+            </a:solidFill>
+            <a:prstDash val="solid"/>
+          </a:ln>
+        </p:spPr>
+      </p:sp>
+      <p:sp>
+        <p:nvSpPr>
+          <p:cNvPr id="8" name="Play-Dreieck">
+            <a:hlinkClick r:id="rId4" tooltip=""/>
+          </p:cNvPr>
+          <p:cNvSpPr/>
+          <p:nvPr/>
+        </p:nvSpPr>
+        <p:spPr>
+          <a:xfrm rot="5400000">
+            <a:off x="7383780" y="1383887"/>
+            <a:ext cx="256032" cy="292608"/>
+          </a:xfrm>
+          <a:prstGeom prst="triangle">
+            <a:avLst/>
+          </a:prstGeom>
+          <a:solidFill>
+            <a:srgbClr val="FFFFFF"/>
+          </a:solidFill>
+          <a:ln w="12700">
+            <a:solidFill>
+              <a:srgbClr val="FFFFFF"/>
+            </a:solidFill>
+            <a:prstDash val="solid"/>
+          </a:ln>
+        </p:spPr>
+      </p:sp>
+      <p:sp>
+        <p:nvSpPr>
+          <p:cNvPr id="9" name="Video-Link"/>
+          <p:cNvSpPr txBox="1"/>
+          <p:nvPr/>
+        </p:nvSpPr>
+        <p:spPr>
+          <a:xfrm>
+            <a:off x="6217920" y="4069080"/>
+            <a:ext cx="2514600" cy="502920"/>
+          </a:xfrm>
+          <a:prstGeom prst="rect">
+            <a:avLst/>
+          </a:prstGeom>
+          <a:noFill/>
+          <a:ln/>
+        </p:spPr>
+        <p:txBody>
+          <a:bodyPr wrap="square" lIns="0" tIns="0" rIns="0" bIns="0" rtlCol="0" anchor="t"/>
+          <a:lstStyle/>
+          <a:p>
+            <a:pPr indent="0" marL="0">
+              <a:buNone/>
+            </a:pPr>
+            <a:r>
+              <a:rPr lang="en-US" sz="1300" b="1" u="sng" dirty="0">
+                <a:solidFill>
+                  <a:schemeClr val="accent1"/>
+                </a:solidFill>
+                <a:hlinkClick r:id="rId5" invalidUrl="" action="" tgtFrame="" tooltip="https://www.youtube.com/watch?v=QSnv7bEbrac" history="1" highlightClick="0" endSnd="0">
+                  <a:extLst>
+                    <a:ext uri="{A12FA001-AC4F-418D-AE19-62706E023703}">
+                      <ahyp:hlinkClr xmlns:ahyp="http://schemas.microsoft.com/office/drawing/2018/hyperlinkcolor" val="tx"/>
+                    </a:ext>
+                  </a:extLst>
+                </a:hlinkClick>
+              </a:rPr>
+              <a:t>▶ Video ansehen</a:t>
+            </a:r>
+            <a:endParaRPr lang="en-US" sz="1300" dirty="0"/>
+          </a:p>
+          <a:p>
+            <a:pPr indent="0" marL="0">
+              <a:buNone/>
+            </a:pPr>
+            <a:r>
+              <a:rPr lang="en-US" sz="1100" dirty="0">
+                <a:solidFill>
+                  <a:schemeClr val="accent3"/>
+                </a:solidFill>
+              </a:rPr>
+              <a:t>How Robots Build Maps (LiDAR + SLAM Explained)</a:t>
+            </a:r>
+            <a:endParaRPr lang="en-US" sz="1300" dirty="0"/>
           </a:p>
         </p:txBody>
       </p:sp>
@@ -8717,28 +8955,83 @@
           </a:p>
         </p:txBody>
       </p:sp>
-      <p:sp>
-        <p:nvSpPr>
-          <p:cNvPr id="6" name="Bildplatzhalter"/>
+      <p:pic>
+        <p:nvPicPr>
+          <p:cNvPr id="6" name="Video-Vorschau" descr="Roboterhände falten ein weißes Handtuch, daneben der kompakte Unitree G1.">
+            <a:hlinkClick r:id="rId2" tooltip="Video auf YouTube öffnen"/>
+          </p:cNvPr>
+          <p:cNvPicPr>
+            <a:picLocks noChangeAspect="1"/>
+          </p:cNvPicPr>
+          <p:nvPr/>
+        </p:nvPicPr>
+        <p:blipFill>
+          <a:blip r:embed="rId1"/>
+          <a:stretch>
+            <a:fillRect/>
+          </a:stretch>
+        </p:blipFill>
+        <p:spPr>
+          <a:xfrm>
+            <a:off x="6217920" y="822960"/>
+            <a:ext cx="2514600" cy="1414463"/>
+          </a:xfrm>
+          <a:prstGeom prst="rect">
+            <a:avLst/>
+          </a:prstGeom>
+        </p:spPr>
+      </p:pic>
+      <p:sp>
+        <p:nvSpPr>
+          <p:cNvPr id="7" name="Play-Kreis">
+            <a:hlinkClick r:id="rId3" tooltip=""/>
+          </p:cNvPr>
           <p:cNvSpPr/>
           <p:nvPr/>
         </p:nvSpPr>
         <p:spPr>
           <a:xfrm>
-            <a:off x="6217920" y="822960"/>
-            <a:ext cx="2514600" cy="2651760"/>
-          </a:xfrm>
-          <a:prstGeom prst="roundRect">
-            <a:avLst>
-              <a:gd name="adj" fmla="val 5455"/>
-            </a:avLst>
+            <a:off x="7155180" y="1210151"/>
+            <a:ext cx="640080" cy="640080"/>
+          </a:xfrm>
+          <a:prstGeom prst="ellipse">
+            <a:avLst/>
           </a:prstGeom>
           <a:solidFill>
-            <a:srgbClr val="12304D"/>
+            <a:srgbClr val="0B1F33">
+              <a:alpha val="75000"/>
+            </a:srgbClr>
+          </a:solidFill>
+          <a:ln w="25400">
+            <a:solidFill>
+              <a:srgbClr val="FFFFFF"/>
+            </a:solidFill>
+            <a:prstDash val="solid"/>
+          </a:ln>
+        </p:spPr>
+      </p:sp>
+      <p:sp>
+        <p:nvSpPr>
+          <p:cNvPr id="8" name="Play-Dreieck">
+            <a:hlinkClick r:id="rId4" tooltip=""/>
+          </p:cNvPr>
+          <p:cNvSpPr/>
+          <p:nvPr/>
+        </p:nvSpPr>
+        <p:spPr>
+          <a:xfrm rot="5400000">
+            <a:off x="7383780" y="1383887"/>
+            <a:ext cx="256032" cy="292608"/>
+          </a:xfrm>
+          <a:prstGeom prst="triangle">
+            <a:avLst/>
+          </a:prstGeom>
+          <a:solidFill>
+            <a:srgbClr val="FFFFFF"/>
           </a:solidFill>
           <a:ln w="12700">
             <a:solidFill>
-              <a:srgbClr val="12304D"/>
+              <a:srgbClr val="FFFFFF"/>
             </a:solidFill>
             <a:prstDash val="solid"/>
           </a:ln>
@@ -8746,53 +9039,14 @@
       </p:sp>
       <p:sp>
         <p:nvSpPr>
-          <p:cNvPr id="7" name="Text 5"/>
-          <p:cNvSpPr txBox="1"/>
-          <p:nvPr/>
-        </p:nvSpPr>
-        <p:spPr>
-          <a:xfrm>
-            <a:off x="6217920" y="960120"/>
-            <a:ext cx="2514600" cy="822960"/>
-          </a:xfrm>
-          <a:prstGeom prst="rect">
-            <a:avLst/>
-          </a:prstGeom>
-          <a:noFill/>
-          <a:ln/>
-        </p:spPr>
-        <p:txBody>
-          <a:bodyPr wrap="square" lIns="0" tIns="0" rIns="0" bIns="0" rtlCol="0" anchor="ctr"/>
-          <a:lstStyle/>
-          <a:p>
-            <a:pPr algn="ctr" indent="0" marL="0">
-              <a:buNone/>
-            </a:pPr>
-            <a:r>
-              <a:rPr lang="en-US" sz="5400" b="1" dirty="0">
-                <a:solidFill>
-                  <a:srgbClr val="FF7A1A"/>
-                </a:solidFill>
-                <a:latin typeface="Cambria" pitchFamily="34" charset="0"/>
-                <a:ea typeface="Cambria" pitchFamily="34" charset="-122"/>
-                <a:cs typeface="Cambria" pitchFamily="34" charset="-120"/>
-              </a:rPr>
-              <a:t>25</a:t>
-            </a:r>
-            <a:endParaRPr lang="en-US" sz="5400" dirty="0"/>
-          </a:p>
-        </p:txBody>
-      </p:sp>
-      <p:sp>
-        <p:nvSpPr>
-          <p:cNvPr id="8" name="Text 6"/>
-          <p:cNvSpPr txBox="1"/>
-          <p:nvPr/>
-        </p:nvSpPr>
-        <p:spPr>
-          <a:xfrm>
-            <a:off x="6446520" y="1874520"/>
-            <a:ext cx="2057400" cy="1463040"/>
+          <p:cNvPr id="9" name="Video-Link"/>
+          <p:cNvSpPr txBox="1"/>
+          <p:nvPr/>
+        </p:nvSpPr>
+        <p:spPr>
+          <a:xfrm>
+            <a:off x="6217920" y="3566160"/>
+            <a:ext cx="2514600" cy="502920"/>
           </a:xfrm>
           <a:prstGeom prst="rect">
             <a:avLst/>
@@ -8804,54 +9058,39 @@
           <a:bodyPr wrap="square" lIns="0" tIns="0" rIns="0" bIns="0" rtlCol="0" anchor="t"/>
           <a:lstStyle/>
           <a:p>
-            <a:pPr algn="ctr" indent="0" marL="0">
-              <a:buNone/>
-            </a:pPr>
-            <a:r>
-              <a:rPr lang="en-US" sz="1300" i="1" dirty="0">
-                <a:solidFill>
-                  <a:srgbClr val="EAF1F7"/>
-                </a:solidFill>
-              </a:rPr>
-              <a:t>Roboterhände falten ein weißes Handtuch, daneben der kompakte Unitree G1.</a:t>
+            <a:pPr indent="0" marL="0">
+              <a:buNone/>
+            </a:pPr>
+            <a:r>
+              <a:rPr lang="en-US" sz="1300" b="1" u="sng" dirty="0">
+                <a:solidFill>
+                  <a:schemeClr val="accent1"/>
+                </a:solidFill>
+                <a:hlinkClick r:id="rId5" invalidUrl="" action="" tgtFrame="" tooltip="https://www.youtube.com/watch?v=Wn2AzxnmxQE" history="1" highlightClick="0" endSnd="0">
+                  <a:extLst>
+                    <a:ext uri="{A12FA001-AC4F-418D-AE19-62706E023703}">
+                      <ahyp:hlinkClr xmlns:ahyp="http://schemas.microsoft.com/office/drawing/2018/hyperlinkcolor" val="tx"/>
+                    </a:ext>
+                  </a:extLst>
+                </a:hlinkClick>
+              </a:rPr>
+              <a:t>▶ Video ansehen</a:t>
             </a:r>
             <a:endParaRPr lang="en-US" sz="1300" dirty="0"/>
           </a:p>
-        </p:txBody>
-      </p:sp>
-      <p:sp>
-        <p:nvSpPr>
-          <p:cNvPr id="9" name="Text 7"/>
-          <p:cNvSpPr txBox="1"/>
-          <p:nvPr/>
-        </p:nvSpPr>
-        <p:spPr>
-          <a:xfrm>
-            <a:off x="6217920" y="3566160"/>
-            <a:ext cx="2514600" cy="228600"/>
-          </a:xfrm>
-          <a:prstGeom prst="rect">
-            <a:avLst/>
-          </a:prstGeom>
-          <a:noFill/>
-          <a:ln/>
-        </p:spPr>
-        <p:txBody>
-          <a:bodyPr wrap="square" lIns="0" tIns="0" rIns="0" bIns="0" rtlCol="0" anchor="ctr"/>
-          <a:lstStyle/>
-          <a:p>
-            <a:pPr algn="ctr" indent="0" marL="0">
-              <a:buNone/>
-            </a:pPr>
-            <a:r>
-              <a:rPr lang="en-US" sz="1000" dirty="0">
-                <a:solidFill>
-                  <a:srgbClr val="5B7C99"/>
-                </a:solidFill>
-              </a:rPr>
-              <a:t>Bildmotiv (Platzhalter)</a:t>
-            </a:r>
-            <a:endParaRPr lang="en-US" sz="1000" dirty="0"/>
+          <a:p>
+            <a:pPr indent="0" marL="0">
+              <a:buNone/>
+            </a:pPr>
+            <a:r>
+              <a:rPr lang="en-US" sz="1100" dirty="0">
+                <a:solidFill>
+                  <a:schemeClr val="accent3"/>
+                </a:solidFill>
+              </a:rPr>
+              <a:t>Unitree G1 Home Task Demo</a:t>
+            </a:r>
+            <a:endParaRPr lang="en-US" sz="1300" dirty="0"/>
           </a:p>
         </p:txBody>
       </p:sp>
@@ -9031,7 +9270,9 @@
       </p:sp>
       <p:pic>
         <p:nvPicPr>
-          <p:cNvPr id="6" name="Foto" descr="Roboter stützt sanft eine ältere Person beim Gehen im Flur eines Seniorenheims.">    </p:cNvPr>
+          <p:cNvPr id="6" name="Video-Vorschau" descr="Roboter stützt sanft eine ältere Person beim Gehen im Flur eines Seniorenheims.">
+            <a:hlinkClick r:id="rId2" tooltip="Video auf YouTube öffnen"/>
+          </p:cNvPr>
           <p:cNvPicPr>
             <a:picLocks noChangeAspect="1"/>
           </p:cNvPicPr>
@@ -9045,8 +9286,8 @@
         </p:blipFill>
         <p:spPr>
           <a:xfrm>
-            <a:off x="6217920" y="457200"/>
-            <a:ext cx="2514600" cy="3291840"/>
+            <a:off x="6217920" y="822960"/>
+            <a:ext cx="2514600" cy="1414463"/>
           </a:xfrm>
           <a:prstGeom prst="rect">
             <a:avLst/>
@@ -9055,37 +9296,114 @@
       </p:pic>
       <p:sp>
         <p:nvSpPr>
-          <p:cNvPr id="7" name="Text 4"/>
-          <p:cNvSpPr txBox="1"/>
-          <p:nvPr/>
-        </p:nvSpPr>
-        <p:spPr>
-          <a:xfrm>
-            <a:off x="6217920" y="3822192"/>
-            <a:ext cx="2514600" cy="201168"/>
-          </a:xfrm>
-          <a:prstGeom prst="rect">
-            <a:avLst/>
-          </a:prstGeom>
-          <a:noFill/>
-          <a:ln/>
-        </p:spPr>
-        <p:txBody>
-          <a:bodyPr wrap="square" lIns="0" tIns="0" rIns="0" bIns="0" rtlCol="0" anchor="ctr"/>
-          <a:lstStyle/>
-          <a:p>
-            <a:pPr indent="0" marL="0">
-              <a:buNone/>
-            </a:pPr>
-            <a:r>
-              <a:rPr lang="en-US" sz="1000" dirty="0">
-                <a:solidFill>
-                  <a:srgbClr val="5B7C99"/>
-                </a:solidFill>
-              </a:rPr>
-              <a:t>Foto: Illustrationsfoto / Wikimedia Commons</a:t>
-            </a:r>
-            <a:endParaRPr lang="en-US" sz="1000" dirty="0"/>
+          <p:cNvPr id="7" name="Play-Kreis">
+            <a:hlinkClick r:id="rId3" tooltip=""/>
+          </p:cNvPr>
+          <p:cNvSpPr/>
+          <p:nvPr/>
+        </p:nvSpPr>
+        <p:spPr>
+          <a:xfrm>
+            <a:off x="7155180" y="1210151"/>
+            <a:ext cx="640080" cy="640080"/>
+          </a:xfrm>
+          <a:prstGeom prst="ellipse">
+            <a:avLst/>
+          </a:prstGeom>
+          <a:solidFill>
+            <a:srgbClr val="0B1F33">
+              <a:alpha val="75000"/>
+            </a:srgbClr>
+          </a:solidFill>
+          <a:ln w="25400">
+            <a:solidFill>
+              <a:srgbClr val="FFFFFF"/>
+            </a:solidFill>
+            <a:prstDash val="solid"/>
+          </a:ln>
+        </p:spPr>
+      </p:sp>
+      <p:sp>
+        <p:nvSpPr>
+          <p:cNvPr id="8" name="Play-Dreieck">
+            <a:hlinkClick r:id="rId4" tooltip=""/>
+          </p:cNvPr>
+          <p:cNvSpPr/>
+          <p:nvPr/>
+        </p:nvSpPr>
+        <p:spPr>
+          <a:xfrm rot="5400000">
+            <a:off x="7383780" y="1383887"/>
+            <a:ext cx="256032" cy="292608"/>
+          </a:xfrm>
+          <a:prstGeom prst="triangle">
+            <a:avLst/>
+          </a:prstGeom>
+          <a:solidFill>
+            <a:srgbClr val="FFFFFF"/>
+          </a:solidFill>
+          <a:ln w="12700">
+            <a:solidFill>
+              <a:srgbClr val="FFFFFF"/>
+            </a:solidFill>
+            <a:prstDash val="solid"/>
+          </a:ln>
+        </p:spPr>
+      </p:sp>
+      <p:sp>
+        <p:nvSpPr>
+          <p:cNvPr id="9" name="Video-Link"/>
+          <p:cNvSpPr txBox="1"/>
+          <p:nvPr/>
+        </p:nvSpPr>
+        <p:spPr>
+          <a:xfrm>
+            <a:off x="6217920" y="4069080"/>
+            <a:ext cx="2514600" cy="502920"/>
+          </a:xfrm>
+          <a:prstGeom prst="rect">
+            <a:avLst/>
+          </a:prstGeom>
+          <a:noFill/>
+          <a:ln/>
+        </p:spPr>
+        <p:txBody>
+          <a:bodyPr wrap="square" lIns="0" tIns="0" rIns="0" bIns="0" rtlCol="0" anchor="t"/>
+          <a:lstStyle/>
+          <a:p>
+            <a:pPr indent="0" marL="0">
+              <a:buNone/>
+            </a:pPr>
+            <a:r>
+              <a:rPr lang="en-US" sz="1300" b="1" u="sng" dirty="0">
+                <a:solidFill>
+                  <a:schemeClr val="accent1"/>
+                </a:solidFill>
+                <a:hlinkClick r:id="rId5" invalidUrl="" action="" tgtFrame="" tooltip="https://www.youtube.com/watch?v=OO-yrowDiAo" history="1" highlightClick="0" endSnd="0">
+                  <a:extLst>
+                    <a:ext uri="{A12FA001-AC4F-418D-AE19-62706E023703}">
+                      <ahyp:hlinkClr xmlns:ahyp="http://schemas.microsoft.com/office/drawing/2018/hyperlinkcolor" val="tx"/>
+                    </a:ext>
+                  </a:extLst>
+                </a:hlinkClick>
+              </a:rPr>
+              <a:t>▶ Video ansehen</a:t>
+            </a:r>
+            <a:endParaRPr lang="en-US" sz="1300" dirty="0"/>
+          </a:p>
+          <a:p>
+            <a:pPr indent="0" marL="0">
+              <a:buNone/>
+            </a:pPr>
+            <a:r>
+              <a:rPr lang="en-US" sz="1100" dirty="0">
+                <a:solidFill>
+                  <a:schemeClr val="accent3"/>
+                </a:solidFill>
+              </a:rPr>
+              <a:t>Meet Abi, the humanoid robot in care homes (Reuters)</a:t>
+            </a:r>
+            <a:endParaRPr lang="en-US" sz="1300" dirty="0"/>
           </a:p>
         </p:txBody>
       </p:sp>
@@ -9263,28 +9581,83 @@
           </a:p>
         </p:txBody>
       </p:sp>
-      <p:sp>
-        <p:nvSpPr>
-          <p:cNvPr id="6" name="Bildplatzhalter"/>
+      <p:pic>
+        <p:nvPicPr>
+          <p:cNvPr id="6" name="Video-Vorschau" descr="Wachstumsdiagramm und eine Tablet-App für die Roboter-Miete.">
+            <a:hlinkClick r:id="rId2" tooltip="Video auf YouTube öffnen"/>
+          </p:cNvPr>
+          <p:cNvPicPr>
+            <a:picLocks noChangeAspect="1"/>
+          </p:cNvPicPr>
+          <p:nvPr/>
+        </p:nvPicPr>
+        <p:blipFill>
+          <a:blip r:embed="rId1"/>
+          <a:stretch>
+            <a:fillRect/>
+          </a:stretch>
+        </p:blipFill>
+        <p:spPr>
+          <a:xfrm>
+            <a:off x="6217920" y="822960"/>
+            <a:ext cx="2514600" cy="1414463"/>
+          </a:xfrm>
+          <a:prstGeom prst="rect">
+            <a:avLst/>
+          </a:prstGeom>
+        </p:spPr>
+      </p:pic>
+      <p:sp>
+        <p:nvSpPr>
+          <p:cNvPr id="7" name="Play-Kreis">
+            <a:hlinkClick r:id="rId3" tooltip=""/>
+          </p:cNvPr>
           <p:cNvSpPr/>
           <p:nvPr/>
         </p:nvSpPr>
         <p:spPr>
           <a:xfrm>
-            <a:off x="6217920" y="822960"/>
-            <a:ext cx="2514600" cy="2651760"/>
-          </a:xfrm>
-          <a:prstGeom prst="roundRect">
-            <a:avLst>
-              <a:gd name="adj" fmla="val 5455"/>
-            </a:avLst>
+            <a:off x="7155180" y="1210151"/>
+            <a:ext cx="640080" cy="640080"/>
+          </a:xfrm>
+          <a:prstGeom prst="ellipse">
+            <a:avLst/>
           </a:prstGeom>
           <a:solidFill>
-            <a:srgbClr val="12304D"/>
+            <a:srgbClr val="0B1F33">
+              <a:alpha val="75000"/>
+            </a:srgbClr>
+          </a:solidFill>
+          <a:ln w="25400">
+            <a:solidFill>
+              <a:srgbClr val="FFFFFF"/>
+            </a:solidFill>
+            <a:prstDash val="solid"/>
+          </a:ln>
+        </p:spPr>
+      </p:sp>
+      <p:sp>
+        <p:nvSpPr>
+          <p:cNvPr id="8" name="Play-Dreieck">
+            <a:hlinkClick r:id="rId4" tooltip=""/>
+          </p:cNvPr>
+          <p:cNvSpPr/>
+          <p:nvPr/>
+        </p:nvSpPr>
+        <p:spPr>
+          <a:xfrm rot="5400000">
+            <a:off x="7383780" y="1383887"/>
+            <a:ext cx="256032" cy="292608"/>
+          </a:xfrm>
+          <a:prstGeom prst="triangle">
+            <a:avLst/>
+          </a:prstGeom>
+          <a:solidFill>
+            <a:srgbClr val="FFFFFF"/>
           </a:solidFill>
           <a:ln w="12700">
             <a:solidFill>
-              <a:srgbClr val="12304D"/>
+              <a:srgbClr val="FFFFFF"/>
             </a:solidFill>
             <a:prstDash val="solid"/>
           </a:ln>
@@ -9292,53 +9665,14 @@
       </p:sp>
       <p:sp>
         <p:nvSpPr>
-          <p:cNvPr id="7" name="Text 5"/>
-          <p:cNvSpPr txBox="1"/>
-          <p:nvPr/>
-        </p:nvSpPr>
-        <p:spPr>
-          <a:xfrm>
-            <a:off x="6217920" y="960120"/>
-            <a:ext cx="2514600" cy="822960"/>
-          </a:xfrm>
-          <a:prstGeom prst="rect">
-            <a:avLst/>
-          </a:prstGeom>
-          <a:noFill/>
-          <a:ln/>
-        </p:spPr>
-        <p:txBody>
-          <a:bodyPr wrap="square" lIns="0" tIns="0" rIns="0" bIns="0" rtlCol="0" anchor="ctr"/>
-          <a:lstStyle/>
-          <a:p>
-            <a:pPr algn="ctr" indent="0" marL="0">
-              <a:buNone/>
-            </a:pPr>
-            <a:r>
-              <a:rPr lang="en-US" sz="5400" b="1" dirty="0">
-                <a:solidFill>
-                  <a:srgbClr val="FF7A1A"/>
-                </a:solidFill>
-                <a:latin typeface="Cambria" pitchFamily="34" charset="0"/>
-                <a:ea typeface="Cambria" pitchFamily="34" charset="-122"/>
-                <a:cs typeface="Cambria" pitchFamily="34" charset="-120"/>
-              </a:rPr>
-              <a:t>27</a:t>
-            </a:r>
-            <a:endParaRPr lang="en-US" sz="5400" dirty="0"/>
-          </a:p>
-        </p:txBody>
-      </p:sp>
-      <p:sp>
-        <p:nvSpPr>
-          <p:cNvPr id="8" name="Text 6"/>
-          <p:cNvSpPr txBox="1"/>
-          <p:nvPr/>
-        </p:nvSpPr>
-        <p:spPr>
-          <a:xfrm>
-            <a:off x="6446520" y="1874520"/>
-            <a:ext cx="2057400" cy="1463040"/>
+          <p:cNvPr id="9" name="Video-Link"/>
+          <p:cNvSpPr txBox="1"/>
+          <p:nvPr/>
+        </p:nvSpPr>
+        <p:spPr>
+          <a:xfrm>
+            <a:off x="6217920" y="3566160"/>
+            <a:ext cx="2514600" cy="502920"/>
           </a:xfrm>
           <a:prstGeom prst="rect">
             <a:avLst/>
@@ -9350,54 +9684,39 @@
           <a:bodyPr wrap="square" lIns="0" tIns="0" rIns="0" bIns="0" rtlCol="0" anchor="t"/>
           <a:lstStyle/>
           <a:p>
-            <a:pPr algn="ctr" indent="0" marL="0">
-              <a:buNone/>
-            </a:pPr>
-            <a:r>
-              <a:rPr lang="en-US" sz="1300" i="1" dirty="0">
-                <a:solidFill>
-                  <a:srgbClr val="EAF1F7"/>
-                </a:solidFill>
-              </a:rPr>
-              <a:t>Wachstumsdiagramm und eine Tablet-App für die Roboter-Miete.</a:t>
+            <a:pPr indent="0" marL="0">
+              <a:buNone/>
+            </a:pPr>
+            <a:r>
+              <a:rPr lang="en-US" sz="1300" b="1" u="sng" dirty="0">
+                <a:solidFill>
+                  <a:schemeClr val="accent1"/>
+                </a:solidFill>
+                <a:hlinkClick r:id="rId5" invalidUrl="" action="" tgtFrame="" tooltip="https://www.youtube.com/watch?v=uw4CrEWjO2Y" history="1" highlightClick="0" endSnd="0">
+                  <a:extLst>
+                    <a:ext uri="{A12FA001-AC4F-418D-AE19-62706E023703}">
+                      <ahyp:hlinkClr xmlns:ahyp="http://schemas.microsoft.com/office/drawing/2018/hyperlinkcolor" val="tx"/>
+                    </a:ext>
+                  </a:extLst>
+                </a:hlinkClick>
+              </a:rPr>
+              <a:t>▶ Video ansehen</a:t>
             </a:r>
             <a:endParaRPr lang="en-US" sz="1300" dirty="0"/>
           </a:p>
-        </p:txBody>
-      </p:sp>
-      <p:sp>
-        <p:nvSpPr>
-          <p:cNvPr id="9" name="Text 7"/>
-          <p:cNvSpPr txBox="1"/>
-          <p:nvPr/>
-        </p:nvSpPr>
-        <p:spPr>
-          <a:xfrm>
-            <a:off x="6217920" y="3566160"/>
-            <a:ext cx="2514600" cy="228600"/>
-          </a:xfrm>
-          <a:prstGeom prst="rect">
-            <a:avLst/>
-          </a:prstGeom>
-          <a:noFill/>
-          <a:ln/>
-        </p:spPr>
-        <p:txBody>
-          <a:bodyPr wrap="square" lIns="0" tIns="0" rIns="0" bIns="0" rtlCol="0" anchor="ctr"/>
-          <a:lstStyle/>
-          <a:p>
-            <a:pPr algn="ctr" indent="0" marL="0">
-              <a:buNone/>
-            </a:pPr>
-            <a:r>
-              <a:rPr lang="en-US" sz="1000" dirty="0">
-                <a:solidFill>
-                  <a:srgbClr val="5B7C99"/>
-                </a:solidFill>
-              </a:rPr>
-              <a:t>Bildmotiv (Platzhalter)</a:t>
-            </a:r>
-            <a:endParaRPr lang="en-US" sz="1000" dirty="0"/>
+          <a:p>
+            <a:pPr indent="0" marL="0">
+              <a:buNone/>
+            </a:pPr>
+            <a:r>
+              <a:rPr lang="en-US" sz="1100" dirty="0">
+                <a:solidFill>
+                  <a:schemeClr val="accent3"/>
+                </a:solidFill>
+              </a:rPr>
+              <a:t>Rentable humanoid robots (CBS Texas)</a:t>
+            </a:r>
+            <a:endParaRPr lang="en-US" sz="1300" dirty="0"/>
           </a:p>
         </p:txBody>
       </p:sp>
@@ -9577,7 +9896,9 @@
       </p:sp>
       <p:pic>
         <p:nvPicPr>
-          <p:cNvPr id="6" name="Foto" descr="Ein digitales Schloss-Symbol vor einem Wohnzimmer-Hintergrund für Datenschutz.">    </p:cNvPr>
+          <p:cNvPr id="6" name="Video-Vorschau" descr="Ein digitales Schloss-Symbol vor einem Wohnzimmer-Hintergrund für Datenschutz.">
+            <a:hlinkClick r:id="rId2" tooltip="Video auf YouTube öffnen"/>
+          </p:cNvPr>
           <p:cNvPicPr>
             <a:picLocks noChangeAspect="1"/>
           </p:cNvPicPr>
@@ -9591,8 +9912,8 @@
         </p:blipFill>
         <p:spPr>
           <a:xfrm>
-            <a:off x="6217920" y="457200"/>
-            <a:ext cx="2514600" cy="3291840"/>
+            <a:off x="6217920" y="822960"/>
+            <a:ext cx="2514600" cy="1414463"/>
           </a:xfrm>
           <a:prstGeom prst="rect">
             <a:avLst/>
@@ -9601,37 +9922,114 @@
       </p:pic>
       <p:sp>
         <p:nvSpPr>
-          <p:cNvPr id="7" name="Text 4"/>
-          <p:cNvSpPr txBox="1"/>
-          <p:nvPr/>
-        </p:nvSpPr>
-        <p:spPr>
-          <a:xfrm>
-            <a:off x="6217920" y="3822192"/>
-            <a:ext cx="2514600" cy="201168"/>
-          </a:xfrm>
-          <a:prstGeom prst="rect">
-            <a:avLst/>
-          </a:prstGeom>
-          <a:noFill/>
-          <a:ln/>
-        </p:spPr>
-        <p:txBody>
-          <a:bodyPr wrap="square" lIns="0" tIns="0" rIns="0" bIns="0" rtlCol="0" anchor="ctr"/>
-          <a:lstStyle/>
-          <a:p>
-            <a:pPr indent="0" marL="0">
-              <a:buNone/>
-            </a:pPr>
-            <a:r>
-              <a:rPr lang="en-US" sz="1000" dirty="0">
-                <a:solidFill>
-                  <a:srgbClr val="5B7C99"/>
-                </a:solidFill>
-              </a:rPr>
-              <a:t>Foto: Illustrationsfoto / Wikimedia Commons</a:t>
-            </a:r>
-            <a:endParaRPr lang="en-US" sz="1000" dirty="0"/>
+          <p:cNvPr id="7" name="Play-Kreis">
+            <a:hlinkClick r:id="rId3" tooltip=""/>
+          </p:cNvPr>
+          <p:cNvSpPr/>
+          <p:nvPr/>
+        </p:nvSpPr>
+        <p:spPr>
+          <a:xfrm>
+            <a:off x="7155180" y="1210151"/>
+            <a:ext cx="640080" cy="640080"/>
+          </a:xfrm>
+          <a:prstGeom prst="ellipse">
+            <a:avLst/>
+          </a:prstGeom>
+          <a:solidFill>
+            <a:srgbClr val="0B1F33">
+              <a:alpha val="75000"/>
+            </a:srgbClr>
+          </a:solidFill>
+          <a:ln w="25400">
+            <a:solidFill>
+              <a:srgbClr val="FFFFFF"/>
+            </a:solidFill>
+            <a:prstDash val="solid"/>
+          </a:ln>
+        </p:spPr>
+      </p:sp>
+      <p:sp>
+        <p:nvSpPr>
+          <p:cNvPr id="8" name="Play-Dreieck">
+            <a:hlinkClick r:id="rId4" tooltip=""/>
+          </p:cNvPr>
+          <p:cNvSpPr/>
+          <p:nvPr/>
+        </p:nvSpPr>
+        <p:spPr>
+          <a:xfrm rot="5400000">
+            <a:off x="7383780" y="1383887"/>
+            <a:ext cx="256032" cy="292608"/>
+          </a:xfrm>
+          <a:prstGeom prst="triangle">
+            <a:avLst/>
+          </a:prstGeom>
+          <a:solidFill>
+            <a:srgbClr val="FFFFFF"/>
+          </a:solidFill>
+          <a:ln w="12700">
+            <a:solidFill>
+              <a:srgbClr val="FFFFFF"/>
+            </a:solidFill>
+            <a:prstDash val="solid"/>
+          </a:ln>
+        </p:spPr>
+      </p:sp>
+      <p:sp>
+        <p:nvSpPr>
+          <p:cNvPr id="9" name="Video-Link"/>
+          <p:cNvSpPr txBox="1"/>
+          <p:nvPr/>
+        </p:nvSpPr>
+        <p:spPr>
+          <a:xfrm>
+            <a:off x="6217920" y="4069080"/>
+            <a:ext cx="2514600" cy="502920"/>
+          </a:xfrm>
+          <a:prstGeom prst="rect">
+            <a:avLst/>
+          </a:prstGeom>
+          <a:noFill/>
+          <a:ln/>
+        </p:spPr>
+        <p:txBody>
+          <a:bodyPr wrap="square" lIns="0" tIns="0" rIns="0" bIns="0" rtlCol="0" anchor="t"/>
+          <a:lstStyle/>
+          <a:p>
+            <a:pPr indent="0" marL="0">
+              <a:buNone/>
+            </a:pPr>
+            <a:r>
+              <a:rPr lang="en-US" sz="1300" b="1" u="sng" dirty="0">
+                <a:solidFill>
+                  <a:schemeClr val="accent1"/>
+                </a:solidFill>
+                <a:hlinkClick r:id="rId5" invalidUrl="" action="" tgtFrame="" tooltip="https://www.youtube.com/watch?v=f3c4mQty_so" history="1" highlightClick="0" endSnd="0">
+                  <a:extLst>
+                    <a:ext uri="{A12FA001-AC4F-418D-AE19-62706E023703}">
+                      <ahyp:hlinkClr xmlns:ahyp="http://schemas.microsoft.com/office/drawing/2018/hyperlinkcolor" val="tx"/>
+                    </a:ext>
+                  </a:extLst>
+                </a:hlinkClick>
+              </a:rPr>
+              <a:t>▶ Video ansehen</a:t>
+            </a:r>
+            <a:endParaRPr lang="en-US" sz="1300" dirty="0"/>
+          </a:p>
+          <a:p>
+            <a:pPr indent="0" marL="0">
+              <a:buNone/>
+            </a:pPr>
+            <a:r>
+              <a:rPr lang="en-US" sz="1100" dirty="0">
+                <a:solidFill>
+                  <a:schemeClr val="accent3"/>
+                </a:solidFill>
+              </a:rPr>
+              <a:t>I Tried the First Humanoid Home Robot (WSJ)</a:t>
+            </a:r>
+            <a:endParaRPr lang="en-US" sz="1300" dirty="0"/>
           </a:p>
         </p:txBody>
       </p:sp>
@@ -10045,7 +10443,9 @@
       </p:sp>
       <p:pic>
         <p:nvPicPr>
-          <p:cNvPr id="6" name="Foto" descr="Ingenieure prüfen neue Materialien und Batterien im Entwicklungszentrum.">    </p:cNvPr>
+          <p:cNvPr id="6" name="Video-Vorschau" descr="Ingenieure prüfen neue Materialien und Batterien im Entwicklungszentrum.">
+            <a:hlinkClick r:id="rId2" tooltip="Video auf YouTube öffnen"/>
+          </p:cNvPr>
           <p:cNvPicPr>
             <a:picLocks noChangeAspect="1"/>
           </p:cNvPicPr>
@@ -10059,8 +10459,8 @@
         </p:blipFill>
         <p:spPr>
           <a:xfrm>
-            <a:off x="6217920" y="457200"/>
-            <a:ext cx="2514600" cy="3291840"/>
+            <a:off x="6217920" y="822960"/>
+            <a:ext cx="2514600" cy="1414463"/>
           </a:xfrm>
           <a:prstGeom prst="rect">
             <a:avLst/>
@@ -10069,37 +10469,114 @@
       </p:pic>
       <p:sp>
         <p:nvSpPr>
-          <p:cNvPr id="7" name="Text 4"/>
-          <p:cNvSpPr txBox="1"/>
-          <p:nvPr/>
-        </p:nvSpPr>
-        <p:spPr>
-          <a:xfrm>
-            <a:off x="6217920" y="3822192"/>
-            <a:ext cx="2514600" cy="201168"/>
-          </a:xfrm>
-          <a:prstGeom prst="rect">
-            <a:avLst/>
-          </a:prstGeom>
-          <a:noFill/>
-          <a:ln/>
-        </p:spPr>
-        <p:txBody>
-          <a:bodyPr wrap="square" lIns="0" tIns="0" rIns="0" bIns="0" rtlCol="0" anchor="ctr"/>
-          <a:lstStyle/>
-          <a:p>
-            <a:pPr indent="0" marL="0">
-              <a:buNone/>
-            </a:pPr>
-            <a:r>
-              <a:rPr lang="en-US" sz="1000" dirty="0">
-                <a:solidFill>
-                  <a:srgbClr val="5B7C99"/>
-                </a:solidFill>
-              </a:rPr>
-              <a:t>Foto: Illustrationsfoto / Wikimedia Commons</a:t>
-            </a:r>
-            <a:endParaRPr lang="en-US" sz="1000" dirty="0"/>
+          <p:cNvPr id="7" name="Play-Kreis">
+            <a:hlinkClick r:id="rId3" tooltip=""/>
+          </p:cNvPr>
+          <p:cNvSpPr/>
+          <p:nvPr/>
+        </p:nvSpPr>
+        <p:spPr>
+          <a:xfrm>
+            <a:off x="7155180" y="1210151"/>
+            <a:ext cx="640080" cy="640080"/>
+          </a:xfrm>
+          <a:prstGeom prst="ellipse">
+            <a:avLst/>
+          </a:prstGeom>
+          <a:solidFill>
+            <a:srgbClr val="0B1F33">
+              <a:alpha val="75000"/>
+            </a:srgbClr>
+          </a:solidFill>
+          <a:ln w="25400">
+            <a:solidFill>
+              <a:srgbClr val="FFFFFF"/>
+            </a:solidFill>
+            <a:prstDash val="solid"/>
+          </a:ln>
+        </p:spPr>
+      </p:sp>
+      <p:sp>
+        <p:nvSpPr>
+          <p:cNvPr id="8" name="Play-Dreieck">
+            <a:hlinkClick r:id="rId4" tooltip=""/>
+          </p:cNvPr>
+          <p:cNvSpPr/>
+          <p:nvPr/>
+        </p:nvSpPr>
+        <p:spPr>
+          <a:xfrm rot="5400000">
+            <a:off x="7383780" y="1383887"/>
+            <a:ext cx="256032" cy="292608"/>
+          </a:xfrm>
+          <a:prstGeom prst="triangle">
+            <a:avLst/>
+          </a:prstGeom>
+          <a:solidFill>
+            <a:srgbClr val="FFFFFF"/>
+          </a:solidFill>
+          <a:ln w="12700">
+            <a:solidFill>
+              <a:srgbClr val="FFFFFF"/>
+            </a:solidFill>
+            <a:prstDash val="solid"/>
+          </a:ln>
+        </p:spPr>
+      </p:sp>
+      <p:sp>
+        <p:nvSpPr>
+          <p:cNvPr id="9" name="Video-Link"/>
+          <p:cNvSpPr txBox="1"/>
+          <p:nvPr/>
+        </p:nvSpPr>
+        <p:spPr>
+          <a:xfrm>
+            <a:off x="6217920" y="4069080"/>
+            <a:ext cx="2514600" cy="502920"/>
+          </a:xfrm>
+          <a:prstGeom prst="rect">
+            <a:avLst/>
+          </a:prstGeom>
+          <a:noFill/>
+          <a:ln/>
+        </p:spPr>
+        <p:txBody>
+          <a:bodyPr wrap="square" lIns="0" tIns="0" rIns="0" bIns="0" rtlCol="0" anchor="t"/>
+          <a:lstStyle/>
+          <a:p>
+            <a:pPr indent="0" marL="0">
+              <a:buNone/>
+            </a:pPr>
+            <a:r>
+              <a:rPr lang="en-US" sz="1300" b="1" u="sng" dirty="0">
+                <a:solidFill>
+                  <a:schemeClr val="accent1"/>
+                </a:solidFill>
+                <a:hlinkClick r:id="rId5" invalidUrl="" action="" tgtFrame="" tooltip="https://www.youtube.com/watch?v=KRyqxhB38JY" history="1" highlightClick="0" endSnd="0">
+                  <a:extLst>
+                    <a:ext uri="{A12FA001-AC4F-418D-AE19-62706E023703}">
+                      <ahyp:hlinkClr xmlns:ahyp="http://schemas.microsoft.com/office/drawing/2018/hyperlinkcolor" val="tx"/>
+                    </a:ext>
+                  </a:extLst>
+                </a:hlinkClick>
+              </a:rPr>
+              <a:t>▶ Video ansehen</a:t>
+            </a:r>
+            <a:endParaRPr lang="en-US" sz="1300" dirty="0"/>
+          </a:p>
+          <a:p>
+            <a:pPr indent="0" marL="0">
+              <a:buNone/>
+            </a:pPr>
+            <a:r>
+              <a:rPr lang="en-US" sz="1100" dirty="0">
+                <a:solidFill>
+                  <a:schemeClr val="accent3"/>
+                </a:solidFill>
+              </a:rPr>
+              <a:t>Battery Life Doubled from 4 to 8 Hours (The Neuron)</a:t>
+            </a:r>
+            <a:endParaRPr lang="en-US" sz="1300" dirty="0"/>
           </a:p>
         </p:txBody>
       </p:sp>
@@ -10279,7 +10756,9 @@
       </p:sp>
       <p:pic>
         <p:nvPicPr>
-          <p:cNvPr id="6" name="Foto" descr="Mensch und humanoider Roboter stehen gemeinsam auf einer Aussichtsplattform.">    </p:cNvPr>
+          <p:cNvPr id="6" name="Video-Vorschau" descr="Mensch und humanoider Roboter stehen gemeinsam auf einer Aussichtsplattform.">
+            <a:hlinkClick r:id="rId2" tooltip="Video auf YouTube öffnen"/>
+          </p:cNvPr>
           <p:cNvPicPr>
             <a:picLocks noChangeAspect="1"/>
           </p:cNvPicPr>
@@ -10293,8 +10772,8 @@
         </p:blipFill>
         <p:spPr>
           <a:xfrm>
-            <a:off x="6217920" y="457200"/>
-            <a:ext cx="2514600" cy="3291840"/>
+            <a:off x="6217920" y="822960"/>
+            <a:ext cx="2514600" cy="1414463"/>
           </a:xfrm>
           <a:prstGeom prst="rect">
             <a:avLst/>
@@ -10303,37 +10782,114 @@
       </p:pic>
       <p:sp>
         <p:nvSpPr>
-          <p:cNvPr id="7" name="Text 4"/>
-          <p:cNvSpPr txBox="1"/>
-          <p:nvPr/>
-        </p:nvSpPr>
-        <p:spPr>
-          <a:xfrm>
-            <a:off x="6217920" y="3822192"/>
-            <a:ext cx="2514600" cy="201168"/>
-          </a:xfrm>
-          <a:prstGeom prst="rect">
-            <a:avLst/>
-          </a:prstGeom>
-          <a:noFill/>
-          <a:ln/>
-        </p:spPr>
-        <p:txBody>
-          <a:bodyPr wrap="square" lIns="0" tIns="0" rIns="0" bIns="0" rtlCol="0" anchor="ctr"/>
-          <a:lstStyle/>
-          <a:p>
-            <a:pPr indent="0" marL="0">
-              <a:buNone/>
-            </a:pPr>
-            <a:r>
-              <a:rPr lang="en-US" sz="1000" dirty="0">
-                <a:solidFill>
-                  <a:srgbClr val="5B7C99"/>
-                </a:solidFill>
-              </a:rPr>
-              <a:t>Foto: Illustrationsfoto / Wikimedia Commons</a:t>
-            </a:r>
-            <a:endParaRPr lang="en-US" sz="1000" dirty="0"/>
+          <p:cNvPr id="7" name="Play-Kreis">
+            <a:hlinkClick r:id="rId3" tooltip=""/>
+          </p:cNvPr>
+          <p:cNvSpPr/>
+          <p:nvPr/>
+        </p:nvSpPr>
+        <p:spPr>
+          <a:xfrm>
+            <a:off x="7155180" y="1210151"/>
+            <a:ext cx="640080" cy="640080"/>
+          </a:xfrm>
+          <a:prstGeom prst="ellipse">
+            <a:avLst/>
+          </a:prstGeom>
+          <a:solidFill>
+            <a:srgbClr val="0B1F33">
+              <a:alpha val="75000"/>
+            </a:srgbClr>
+          </a:solidFill>
+          <a:ln w="25400">
+            <a:solidFill>
+              <a:srgbClr val="FFFFFF"/>
+            </a:solidFill>
+            <a:prstDash val="solid"/>
+          </a:ln>
+        </p:spPr>
+      </p:sp>
+      <p:sp>
+        <p:nvSpPr>
+          <p:cNvPr id="8" name="Play-Dreieck">
+            <a:hlinkClick r:id="rId4" tooltip=""/>
+          </p:cNvPr>
+          <p:cNvSpPr/>
+          <p:nvPr/>
+        </p:nvSpPr>
+        <p:spPr>
+          <a:xfrm rot="5400000">
+            <a:off x="7383780" y="1383887"/>
+            <a:ext cx="256032" cy="292608"/>
+          </a:xfrm>
+          <a:prstGeom prst="triangle">
+            <a:avLst/>
+          </a:prstGeom>
+          <a:solidFill>
+            <a:srgbClr val="FFFFFF"/>
+          </a:solidFill>
+          <a:ln w="12700">
+            <a:solidFill>
+              <a:srgbClr val="FFFFFF"/>
+            </a:solidFill>
+            <a:prstDash val="solid"/>
+          </a:ln>
+        </p:spPr>
+      </p:sp>
+      <p:sp>
+        <p:nvSpPr>
+          <p:cNvPr id="9" name="Video-Link"/>
+          <p:cNvSpPr txBox="1"/>
+          <p:nvPr/>
+        </p:nvSpPr>
+        <p:spPr>
+          <a:xfrm>
+            <a:off x="6217920" y="4069080"/>
+            <a:ext cx="2514600" cy="502920"/>
+          </a:xfrm>
+          <a:prstGeom prst="rect">
+            <a:avLst/>
+          </a:prstGeom>
+          <a:noFill/>
+          <a:ln/>
+        </p:spPr>
+        <p:txBody>
+          <a:bodyPr wrap="square" lIns="0" tIns="0" rIns="0" bIns="0" rtlCol="0" anchor="t"/>
+          <a:lstStyle/>
+          <a:p>
+            <a:pPr indent="0" marL="0">
+              <a:buNone/>
+            </a:pPr>
+            <a:r>
+              <a:rPr lang="en-US" sz="1300" b="1" u="sng" dirty="0">
+                <a:solidFill>
+                  <a:schemeClr val="accent1"/>
+                </a:solidFill>
+                <a:hlinkClick r:id="rId5" invalidUrl="" action="" tgtFrame="" tooltip="https://www.youtube.com/watch?v=U1JJN1tEvJw" history="1" highlightClick="0" endSnd="0">
+                  <a:extLst>
+                    <a:ext uri="{A12FA001-AC4F-418D-AE19-62706E023703}">
+                      <ahyp:hlinkClr xmlns:ahyp="http://schemas.microsoft.com/office/drawing/2018/hyperlinkcolor" val="tx"/>
+                    </a:ext>
+                  </a:extLst>
+                </a:hlinkClick>
+              </a:rPr>
+              <a:t>▶ Video ansehen</a:t>
+            </a:r>
+            <a:endParaRPr lang="en-US" sz="1300" dirty="0"/>
+          </a:p>
+          <a:p>
+            <a:pPr indent="0" marL="0">
+              <a:buNone/>
+            </a:pPr>
+            <a:r>
+              <a:rPr lang="en-US" sz="1100" dirty="0">
+                <a:solidFill>
+                  <a:schemeClr val="accent3"/>
+                </a:solidFill>
+              </a:rPr>
+              <a:t>Will humans and robots work together soon? (CGTN)</a:t>
+            </a:r>
+            <a:endParaRPr lang="en-US" sz="1300" dirty="0"/>
           </a:p>
         </p:txBody>
       </p:sp>

</xml_diff>